<commit_message>
Deck: add a Submission Links slide with fillable, clickable links
New final slide with GitHub Repository and Video Demo rows. Both show
"[Insert Link]" until filled.

The links are two constants at the top of tools_make_deck.py, GITHUB_URL and
VIDEO_URL. Once set and the generator is re-run, each URL is written as a real
hyperlink on the text AND as a click action on its whole card, so it works in
slideshow mode rather than only when the text is selected. The live viewer line
beneath is also a working hyperlink.

Verified rather than assumed: built a copy with test URLs and inspected the
slide XML - both text runs carry the hyperlink address and both cards carry
click actions - then rendered both the placeholder and the filled version through
PowerPoint to confirm the layout holds with and without a URL.
</commit_message>
<xml_diff>
--- a/deck.pptx
+++ b/deck.pptx
@@ -15,6 +15,7 @@
     <p:sldId id="263" r:id="rId14"/>
     <p:sldId id="264" r:id="rId15"/>
     <p:sldId id="265" r:id="rId16"/>
+    <p:sldId id="266" r:id="rId17"/>
   </p:sldIdLst>
   <p:sldSz cx="12191695" cy="6858000" type="screen4x3"/>
   <p:notesSz cx="6858000" cy="9144000"/>
@@ -4298,6 +4299,500 @@
                   <a:srgbClr val="E2551F"/>
                 </a:solidFill>
                 <a:latin typeface="Consolas"/>
+              </a:rPr>
+              <a:t>soc-agent-trace-viewer.vercel.app</a:t>
+            </a:r>
+          </a:p>
+        </p:txBody>
+      </p:sp>
+    </p:spTree>
+  </p:cSld>
+  <p:clrMapOvr>
+    <a:masterClrMapping/>
+  </p:clrMapOvr>
+</p:sld>
+</file>
+
+<file path=ppt/slides/slide11.xml><?xml version="1.0" encoding="utf-8"?>
+<p:sld xmlns:a="http://schemas.openxmlformats.org/drawingml/2006/main" xmlns:p="http://schemas.openxmlformats.org/presentationml/2006/main" xmlns:r="http://schemas.openxmlformats.org/officeDocument/2006/relationships">
+  <p:cSld>
+    <p:spTree>
+      <p:nvGrpSpPr>
+        <p:cNvPr id="1" name=""/>
+        <p:cNvGrpSpPr/>
+        <p:nvPr/>
+      </p:nvGrpSpPr>
+      <p:grpSpPr/>
+      <p:sp>
+        <p:nvSpPr>
+          <p:cNvPr id="2" name="Rectangle 1"/>
+          <p:cNvSpPr/>
+          <p:nvPr/>
+        </p:nvSpPr>
+        <p:spPr>
+          <a:xfrm>
+            <a:off x="0" y="0"/>
+            <a:ext cx="12191695" cy="6858000"/>
+          </a:xfrm>
+          <a:prstGeom prst="rect">
+            <a:avLst/>
+          </a:prstGeom>
+          <a:solidFill>
+            <a:srgbClr val="FFFAF0"/>
+          </a:solidFill>
+          <a:ln>
+            <a:noFill/>
+          </a:ln>
+          <a:effectLst/>
+        </p:spPr>
+        <p:style>
+          <a:lnRef idx="1">
+            <a:schemeClr val="accent1"/>
+          </a:lnRef>
+          <a:fillRef idx="3">
+            <a:schemeClr val="accent1"/>
+          </a:fillRef>
+          <a:effectRef idx="2">
+            <a:schemeClr val="accent1"/>
+          </a:effectRef>
+          <a:fontRef idx="minor">
+            <a:schemeClr val="lt1"/>
+          </a:fontRef>
+        </p:style>
+        <p:txBody>
+          <a:bodyPr rtlCol="0" anchor="ctr"/>
+          <a:lstStyle/>
+          <a:p>
+            <a:pPr algn="ctr"/>
+          </a:p>
+        </p:txBody>
+      </p:sp>
+      <p:sp>
+        <p:nvSpPr>
+          <p:cNvPr id="3" name="TextBox 2"/>
+          <p:cNvSpPr txBox="1"/>
+          <p:nvPr/>
+        </p:nvSpPr>
+        <p:spPr>
+          <a:xfrm>
+            <a:off x="777240" y="457200"/>
+            <a:ext cx="8961120" cy="274320"/>
+          </a:xfrm>
+          <a:prstGeom prst="rect">
+            <a:avLst/>
+          </a:prstGeom>
+          <a:noFill/>
+        </p:spPr>
+        <p:txBody>
+          <a:bodyPr wrap="square" lIns="0" rIns="0" tIns="0" bIns="0">
+            <a:spAutoFit/>
+          </a:bodyPr>
+          <a:lstStyle/>
+          <a:p>
+            <a:pPr algn="l">
+              <a:lnSpc>
+                <a:spcPct val="125000"/>
+              </a:lnSpc>
+              <a:spcAft>
+                <a:spcPts val="600"/>
+              </a:spcAft>
+            </a:pPr>
+            <a:r>
+              <a:rPr sz="1200" b="1">
+                <a:solidFill>
+                  <a:srgbClr val="E2551F"/>
+                </a:solidFill>
+                <a:latin typeface="Segoe UI"/>
+              </a:rPr>
+              <a:t>SUBMISSION</a:t>
+            </a:r>
+          </a:p>
+        </p:txBody>
+      </p:sp>
+      <p:sp>
+        <p:nvSpPr>
+          <p:cNvPr id="4" name="TextBox 3"/>
+          <p:cNvSpPr txBox="1"/>
+          <p:nvPr/>
+        </p:nvSpPr>
+        <p:spPr>
+          <a:xfrm>
+            <a:off x="777240" y="777240"/>
+            <a:ext cx="8961120" cy="822960"/>
+          </a:xfrm>
+          <a:prstGeom prst="rect">
+            <a:avLst/>
+          </a:prstGeom>
+          <a:noFill/>
+        </p:spPr>
+        <p:txBody>
+          <a:bodyPr wrap="square" lIns="0" rIns="0" tIns="0" bIns="0">
+            <a:spAutoFit/>
+          </a:bodyPr>
+          <a:lstStyle/>
+          <a:p>
+            <a:pPr algn="l">
+              <a:lnSpc>
+                <a:spcPct val="125000"/>
+              </a:lnSpc>
+              <a:spcAft>
+                <a:spcPts val="600"/>
+              </a:spcAft>
+            </a:pPr>
+            <a:r>
+              <a:rPr sz="3100" b="1">
+                <a:solidFill>
+                  <a:srgbClr val="1C1C1E"/>
+                </a:solidFill>
+                <a:latin typeface="Georgia"/>
+              </a:rPr>
+              <a:t>Submission Links</a:t>
+            </a:r>
+          </a:p>
+        </p:txBody>
+      </p:sp>
+      <p:sp>
+        <p:nvSpPr>
+          <p:cNvPr id="5" name="Rounded Rectangle 4"/>
+          <p:cNvSpPr/>
+          <p:nvPr/>
+        </p:nvSpPr>
+        <p:spPr>
+          <a:xfrm>
+            <a:off x="777240" y="1874519"/>
+            <a:ext cx="10607040" cy="1417320"/>
+          </a:xfrm>
+          <a:prstGeom prst="roundRect">
+            <a:avLst>
+              <a:gd name="adj" fmla="val 4000"/>
+            </a:avLst>
+          </a:prstGeom>
+          <a:solidFill>
+            <a:srgbClr val="FFFFFF"/>
+          </a:solidFill>
+          <a:ln w="12700">
+            <a:solidFill>
+              <a:srgbClr val="E2D8CC"/>
+            </a:solidFill>
+          </a:ln>
+          <a:effectLst/>
+        </p:spPr>
+        <p:style>
+          <a:lnRef idx="1">
+            <a:schemeClr val="accent1"/>
+          </a:lnRef>
+          <a:fillRef idx="3">
+            <a:schemeClr val="accent1"/>
+          </a:fillRef>
+          <a:effectRef idx="2">
+            <a:schemeClr val="accent1"/>
+          </a:effectRef>
+          <a:fontRef idx="minor">
+            <a:schemeClr val="lt1"/>
+          </a:fontRef>
+        </p:style>
+        <p:txBody>
+          <a:bodyPr rtlCol="0" anchor="ctr"/>
+          <a:lstStyle/>
+          <a:p>
+            <a:pPr algn="ctr"/>
+          </a:p>
+        </p:txBody>
+      </p:sp>
+      <p:sp>
+        <p:nvSpPr>
+          <p:cNvPr id="6" name="Rectangle 5"/>
+          <p:cNvSpPr/>
+          <p:nvPr/>
+        </p:nvSpPr>
+        <p:spPr>
+          <a:xfrm>
+            <a:off x="777240" y="1874519"/>
+            <a:ext cx="50292" cy="1417320"/>
+          </a:xfrm>
+          <a:prstGeom prst="rect">
+            <a:avLst/>
+          </a:prstGeom>
+          <a:solidFill>
+            <a:srgbClr val="E2551F"/>
+          </a:solidFill>
+          <a:ln>
+            <a:noFill/>
+          </a:ln>
+          <a:effectLst/>
+        </p:spPr>
+        <p:style>
+          <a:lnRef idx="1">
+            <a:schemeClr val="accent1"/>
+          </a:lnRef>
+          <a:fillRef idx="3">
+            <a:schemeClr val="accent1"/>
+          </a:fillRef>
+          <a:effectRef idx="2">
+            <a:schemeClr val="accent1"/>
+          </a:effectRef>
+          <a:fontRef idx="minor">
+            <a:schemeClr val="lt1"/>
+          </a:fontRef>
+        </p:style>
+        <p:txBody>
+          <a:bodyPr rtlCol="0" anchor="ctr"/>
+          <a:lstStyle/>
+          <a:p>
+            <a:pPr algn="ctr"/>
+          </a:p>
+        </p:txBody>
+      </p:sp>
+      <p:sp>
+        <p:nvSpPr>
+          <p:cNvPr id="7" name="TextBox 6"/>
+          <p:cNvSpPr txBox="1"/>
+          <p:nvPr/>
+        </p:nvSpPr>
+        <p:spPr>
+          <a:xfrm>
+            <a:off x="1143000" y="2103119"/>
+            <a:ext cx="9966960" cy="1005840"/>
+          </a:xfrm>
+          <a:prstGeom prst="rect">
+            <a:avLst/>
+          </a:prstGeom>
+          <a:noFill/>
+        </p:spPr>
+        <p:txBody>
+          <a:bodyPr wrap="square" lIns="0" rIns="0" tIns="0" bIns="0">
+            <a:spAutoFit/>
+          </a:bodyPr>
+          <a:lstStyle/>
+          <a:p>
+            <a:r>
+              <a:rPr sz="2200">
+                <a:latin typeface="Segoe UI Emoji"/>
+              </a:rPr>
+              <a:t>🔗  </a:t>
+            </a:r>
+            <a:r>
+              <a:rPr sz="2200" b="1">
+                <a:solidFill>
+                  <a:srgbClr val="1C1C1E"/>
+                </a:solidFill>
+                <a:latin typeface="Segoe UI"/>
+              </a:rPr>
+              <a:t>GitHub Repository</a:t>
+            </a:r>
+          </a:p>
+          <a:p>
+            <a:pPr>
+              <a:spcBef>
+                <a:spcPts val="800"/>
+              </a:spcBef>
+            </a:pPr>
+            <a:r>
+              <a:rPr sz="1700">
+                <a:solidFill>
+                  <a:srgbClr val="8A8A94"/>
+                </a:solidFill>
+                <a:latin typeface="Consolas"/>
+              </a:rPr>
+              <a:t>[Insert Link]</a:t>
+            </a:r>
+          </a:p>
+        </p:txBody>
+      </p:sp>
+      <p:sp>
+        <p:nvSpPr>
+          <p:cNvPr id="8" name="Rounded Rectangle 7"/>
+          <p:cNvSpPr/>
+          <p:nvPr/>
+        </p:nvSpPr>
+        <p:spPr>
+          <a:xfrm>
+            <a:off x="777240" y="3520440"/>
+            <a:ext cx="10607040" cy="1417320"/>
+          </a:xfrm>
+          <a:prstGeom prst="roundRect">
+            <a:avLst>
+              <a:gd name="adj" fmla="val 4000"/>
+            </a:avLst>
+          </a:prstGeom>
+          <a:solidFill>
+            <a:srgbClr val="FFFFFF"/>
+          </a:solidFill>
+          <a:ln w="12700">
+            <a:solidFill>
+              <a:srgbClr val="E2D8CC"/>
+            </a:solidFill>
+          </a:ln>
+          <a:effectLst/>
+        </p:spPr>
+        <p:style>
+          <a:lnRef idx="1">
+            <a:schemeClr val="accent1"/>
+          </a:lnRef>
+          <a:fillRef idx="3">
+            <a:schemeClr val="accent1"/>
+          </a:fillRef>
+          <a:effectRef idx="2">
+            <a:schemeClr val="accent1"/>
+          </a:effectRef>
+          <a:fontRef idx="minor">
+            <a:schemeClr val="lt1"/>
+          </a:fontRef>
+        </p:style>
+        <p:txBody>
+          <a:bodyPr rtlCol="0" anchor="ctr"/>
+          <a:lstStyle/>
+          <a:p>
+            <a:pPr algn="ctr"/>
+          </a:p>
+        </p:txBody>
+      </p:sp>
+      <p:sp>
+        <p:nvSpPr>
+          <p:cNvPr id="9" name="Rectangle 8"/>
+          <p:cNvSpPr/>
+          <p:nvPr/>
+        </p:nvSpPr>
+        <p:spPr>
+          <a:xfrm>
+            <a:off x="777240" y="3520440"/>
+            <a:ext cx="50292" cy="1417320"/>
+          </a:xfrm>
+          <a:prstGeom prst="rect">
+            <a:avLst/>
+          </a:prstGeom>
+          <a:solidFill>
+            <a:srgbClr val="E2551F"/>
+          </a:solidFill>
+          <a:ln>
+            <a:noFill/>
+          </a:ln>
+          <a:effectLst/>
+        </p:spPr>
+        <p:style>
+          <a:lnRef idx="1">
+            <a:schemeClr val="accent1"/>
+          </a:lnRef>
+          <a:fillRef idx="3">
+            <a:schemeClr val="accent1"/>
+          </a:fillRef>
+          <a:effectRef idx="2">
+            <a:schemeClr val="accent1"/>
+          </a:effectRef>
+          <a:fontRef idx="minor">
+            <a:schemeClr val="lt1"/>
+          </a:fontRef>
+        </p:style>
+        <p:txBody>
+          <a:bodyPr rtlCol="0" anchor="ctr"/>
+          <a:lstStyle/>
+          <a:p>
+            <a:pPr algn="ctr"/>
+          </a:p>
+        </p:txBody>
+      </p:sp>
+      <p:sp>
+        <p:nvSpPr>
+          <p:cNvPr id="10" name="TextBox 9"/>
+          <p:cNvSpPr txBox="1"/>
+          <p:nvPr/>
+        </p:nvSpPr>
+        <p:spPr>
+          <a:xfrm>
+            <a:off x="1143000" y="3749040"/>
+            <a:ext cx="9966960" cy="1005840"/>
+          </a:xfrm>
+          <a:prstGeom prst="rect">
+            <a:avLst/>
+          </a:prstGeom>
+          <a:noFill/>
+        </p:spPr>
+        <p:txBody>
+          <a:bodyPr wrap="square" lIns="0" rIns="0" tIns="0" bIns="0">
+            <a:spAutoFit/>
+          </a:bodyPr>
+          <a:lstStyle/>
+          <a:p>
+            <a:r>
+              <a:rPr sz="2200">
+                <a:latin typeface="Segoe UI Emoji"/>
+              </a:rPr>
+              <a:t>▶️  </a:t>
+            </a:r>
+            <a:r>
+              <a:rPr sz="2200" b="1">
+                <a:solidFill>
+                  <a:srgbClr val="1C1C1E"/>
+                </a:solidFill>
+                <a:latin typeface="Segoe UI"/>
+              </a:rPr>
+              <a:t>Video Demo</a:t>
+            </a:r>
+          </a:p>
+          <a:p>
+            <a:pPr>
+              <a:spcBef>
+                <a:spcPts val="800"/>
+              </a:spcBef>
+            </a:pPr>
+            <a:r>
+              <a:rPr sz="1700">
+                <a:solidFill>
+                  <a:srgbClr val="8A8A94"/>
+                </a:solidFill>
+                <a:latin typeface="Consolas"/>
+              </a:rPr>
+              <a:t>[Insert Link]</a:t>
+            </a:r>
+          </a:p>
+        </p:txBody>
+      </p:sp>
+      <p:sp>
+        <p:nvSpPr>
+          <p:cNvPr id="11" name="TextBox 10"/>
+          <p:cNvSpPr txBox="1"/>
+          <p:nvPr/>
+        </p:nvSpPr>
+        <p:spPr>
+          <a:xfrm>
+            <a:off x="777240" y="5257800"/>
+            <a:ext cx="10607040" cy="365760"/>
+          </a:xfrm>
+          <a:prstGeom prst="rect">
+            <a:avLst/>
+          </a:prstGeom>
+          <a:noFill/>
+        </p:spPr>
+        <p:txBody>
+          <a:bodyPr wrap="square" lIns="0" rIns="0" tIns="0" bIns="0">
+            <a:spAutoFit/>
+          </a:bodyPr>
+          <a:lstStyle/>
+          <a:p>
+            <a:pPr algn="l">
+              <a:lnSpc>
+                <a:spcPct val="125000"/>
+              </a:lnSpc>
+              <a:spcAft>
+                <a:spcPts val="600"/>
+              </a:spcAft>
+            </a:pPr>
+            <a:r>
+              <a:rPr sz="1400" b="0">
+                <a:solidFill>
+                  <a:srgbClr val="4A4A52"/>
+                </a:solidFill>
+                <a:latin typeface="Segoe UI"/>
+              </a:rPr>
+              <a:t>Live viewer:  </a:t>
+            </a:r>
+            <a:r>
+              <a:rPr sz="1400" u="sng">
+                <a:solidFill>
+                  <a:srgbClr val="E2551F"/>
+                </a:solidFill>
+                <a:latin typeface="Consolas"/>
+                <a:hlinkClick r:id="rId2"/>
               </a:rPr>
               <a:t>soc-agent-trace-viewer.vercel.app</a:t>
             </a:r>

</xml_diff>

<commit_message>
Deck: team name, slide 9 title, and a live GitHub link
- Slide 1: team name set to Dropout, replacing the placeholder.
- Slide 9: title changed to "What stops it doing something wrong".
- Slide 11: GitHub Repository now links to the repo. The URL is a hyperlink on
  the text and a click action on the whole card, so it works in slideshow mode.
  Video Demo stays "[Insert Link]" until the shareable video link is supplied.

Checked in the saved file (both link types present, video placeholder intact, no
remaining placeholder or old title text anywhere in the deck) and rendered
slides 1, 9 and 11 through PowerPoint; the full repository URL fits on one line.
</commit_message>
<xml_diff>
--- a/deck.pptx
+++ b/deck.pptx
@@ -3540,7 +3540,7 @@
                 </a:solidFill>
                 <a:latin typeface="Segoe UI"/>
               </a:rPr>
-              <a:t>[ your team name here ]</a:t>
+              <a:t>Dropout</a:t>
             </a:r>
           </a:p>
         </p:txBody>
@@ -4453,7 +4453,9 @@
       </p:sp>
       <p:sp>
         <p:nvSpPr>
-          <p:cNvPr id="5" name="Rounded Rectangle 4"/>
+          <p:cNvPr id="5" name="Rounded Rectangle 4">
+            <a:hlinkClick r:id="rId2"/>
+          </p:cNvPr>
           <p:cNvSpPr/>
           <p:nvPr/>
         </p:nvSpPr>
@@ -4588,13 +4590,14 @@
               </a:spcBef>
             </a:pPr>
             <a:r>
-              <a:rPr sz="1700">
-                <a:solidFill>
-                  <a:srgbClr val="8A8A94"/>
+              <a:rPr u="sng" sz="1700">
+                <a:solidFill>
+                  <a:srgbClr val="E2551F"/>
                 </a:solidFill>
                 <a:latin typeface="Consolas"/>
-              </a:rPr>
-              <a:t>[Insert Link]</a:t>
+                <a:hlinkClick r:id="rId2"/>
+              </a:rPr>
+              <a:t>https://github.com/Graybeep/Dropout_Autonomous-SOC-Investigation-Response-Agent</a:t>
             </a:r>
           </a:p>
         </p:txBody>
@@ -4792,7 +4795,7 @@
                   <a:srgbClr val="E2551F"/>
                 </a:solidFill>
                 <a:latin typeface="Consolas"/>
-                <a:hlinkClick r:id="rId2"/>
+                <a:hlinkClick r:id="rId3"/>
               </a:rPr>
               <a:t>soc-agent-trace-viewer.vercel.app</a:t>
             </a:r>
@@ -15059,7 +15062,7 @@
                 </a:solidFill>
                 <a:latin typeface="Georgia"/>
               </a:rPr>
-              <a:t>What stops it doing something stupid</a:t>
+              <a:t>What stops it doing something wrong</a:t>
             </a:r>
           </a:p>
         </p:txBody>

</xml_diff>

<commit_message>
Deck: repository diagram on slide 4, real screenshot on slide 8, exact quote on slide 6
Slide 4 now shows the same architecture diagram as the README and
docs/ARCHITECTURE.md, rendered at 2x from the SVG into docs/architecture.png, so
the deck and the repository can no longer show different drawings. The slide
copy omits the SVG's own heading and legend, which the slide supplies.

A first attempt cropped the heading off with a fixed cut and clipped the Human
Interaction box, one of the nine components, because it sits beside that heading.
Caught by rendering the slide through PowerPoint; replaced with a variant that
removes the heading text and tightens the canvas instead of cropping.

Also carried in this deck build, pending since PowerPoint had the file open:
slide 6 quotes the agent exactly ("Good catch - I need to fix two issues"), and
slide 8 shows the real captured viewer instead of a drawn mock-up.

All eleven slides rendered and checked; nothing falls outside a slide.
</commit_message>
<xml_diff>
--- a/deck.pptx
+++ b/deck.pptx
@@ -7469,7 +7469,7 @@
                 </a:solidFill>
                 <a:latin typeface="Georgia"/>
               </a:rPr>
-              <a:t>Nine components, one entry point</a:t>
+              <a:t>Nine components, one loop</a:t>
             </a:r>
           </a:p>
         </p:txBody>
@@ -7529,54 +7529,30 @@
           </a:p>
         </p:txBody>
       </p:sp>
-      <p:sp>
-        <p:nvSpPr>
-          <p:cNvPr id="6" name="Rounded Rectangle 5"/>
-          <p:cNvSpPr/>
-          <p:nvPr/>
-        </p:nvSpPr>
-        <p:spPr>
-          <a:xfrm>
-            <a:off x="777240" y="1627632"/>
-            <a:ext cx="10607040" cy="713232"/>
-          </a:xfrm>
-          <a:prstGeom prst="roundRect">
-            <a:avLst>
-              <a:gd name="adj" fmla="val 12000"/>
-            </a:avLst>
-          </a:prstGeom>
-          <a:solidFill>
-            <a:srgbClr val="FFF3E4"/>
-          </a:solidFill>
-          <a:ln>
-            <a:solidFill>
-              <a:srgbClr val="E2551F"/>
-            </a:solidFill>
-          </a:ln>
-          <a:effectLst/>
-        </p:spPr>
-        <p:style>
-          <a:lnRef idx="1">
-            <a:schemeClr val="accent1"/>
-          </a:lnRef>
-          <a:fillRef idx="3">
-            <a:schemeClr val="accent1"/>
-          </a:fillRef>
-          <a:effectRef idx="2">
-            <a:schemeClr val="accent1"/>
-          </a:effectRef>
-          <a:fontRef idx="minor">
-            <a:schemeClr val="lt1"/>
-          </a:fontRef>
-        </p:style>
-        <p:txBody>
-          <a:bodyPr rtlCol="0" anchor="ctr"/>
-          <a:lstStyle/>
-          <a:p>
-            <a:pPr algn="ctr"/>
-          </a:p>
-        </p:txBody>
-      </p:sp>
+      <p:pic>
+        <p:nvPicPr>
+          <p:cNvPr id="6" name="Picture 5" descr="architecture.png"/>
+          <p:cNvPicPr>
+            <a:picLocks noChangeAspect="1"/>
+          </p:cNvPicPr>
+          <p:nvPr/>
+        </p:nvPicPr>
+        <p:blipFill>
+          <a:blip r:embed="rId2"/>
+          <a:stretch>
+            <a:fillRect/>
+          </a:stretch>
+        </p:blipFill>
+        <p:spPr>
+          <a:xfrm>
+            <a:off x="2485622" y="1554480"/>
+            <a:ext cx="7190276" cy="4983480"/>
+          </a:xfrm>
+          <a:prstGeom prst="rect">
+            <a:avLst/>
+          </a:prstGeom>
+        </p:spPr>
+      </p:pic>
       <p:sp>
         <p:nvSpPr>
           <p:cNvPr id="7" name="TextBox 6"/>
@@ -7585,1219 +7561,7 @@
         </p:nvSpPr>
         <p:spPr>
           <a:xfrm>
-            <a:off x="960120" y="1700784"/>
-            <a:ext cx="2743200" cy="228600"/>
-          </a:xfrm>
-          <a:prstGeom prst="rect">
-            <a:avLst/>
-          </a:prstGeom>
-          <a:noFill/>
-        </p:spPr>
-        <p:txBody>
-          <a:bodyPr wrap="square" lIns="0" rIns="0" tIns="0" bIns="0">
-            <a:spAutoFit/>
-          </a:bodyPr>
-          <a:lstStyle/>
-          <a:p>
-            <a:pPr algn="l">
-              <a:lnSpc>
-                <a:spcPct val="125000"/>
-              </a:lnSpc>
-              <a:spcAft>
-                <a:spcPts val="600"/>
-              </a:spcAft>
-            </a:pPr>
-            <a:r>
-              <a:rPr sz="1050" b="1">
-                <a:solidFill>
-                  <a:srgbClr val="E2551F"/>
-                </a:solidFill>
-                <a:latin typeface="Segoe UI"/>
-              </a:rPr>
-              <a:t>EXTERNAL SYSTEMS</a:t>
-            </a:r>
-          </a:p>
-        </p:txBody>
-      </p:sp>
-      <p:sp>
-        <p:nvSpPr>
-          <p:cNvPr id="8" name="TextBox 7"/>
-          <p:cNvSpPr txBox="1"/>
-          <p:nvPr/>
-        </p:nvSpPr>
-        <p:spPr>
-          <a:xfrm>
-            <a:off x="960120" y="1947672"/>
-            <a:ext cx="10241280" cy="320040"/>
-          </a:xfrm>
-          <a:prstGeom prst="rect">
-            <a:avLst/>
-          </a:prstGeom>
-          <a:noFill/>
-        </p:spPr>
-        <p:txBody>
-          <a:bodyPr wrap="square" lIns="0" rIns="0" tIns="0" bIns="0">
-            <a:spAutoFit/>
-          </a:bodyPr>
-          <a:lstStyle/>
-          <a:p>
-            <a:pPr algn="l">
-              <a:lnSpc>
-                <a:spcPct val="125000"/>
-              </a:lnSpc>
-              <a:spcAft>
-                <a:spcPts val="600"/>
-              </a:spcAft>
-            </a:pPr>
-            <a:r>
-              <a:rPr sz="1100" b="0">
-                <a:solidFill>
-                  <a:srgbClr val="4A4A52"/>
-                </a:solidFill>
-                <a:latin typeface="Segoe UI"/>
-              </a:rPr>
-              <a:t>alerts  ·  asset inventory  ·  CVE knowledge base  ·  configuration  ·  host logs  ·  packet metadata  ·  firewall state (read AND written)</a:t>
-            </a:r>
-          </a:p>
-        </p:txBody>
-      </p:sp>
-      <p:sp>
-        <p:nvSpPr>
-          <p:cNvPr id="9" name="Rounded Rectangle 8"/>
-          <p:cNvSpPr/>
-          <p:nvPr/>
-        </p:nvSpPr>
-        <p:spPr>
-          <a:xfrm>
-            <a:off x="777240" y="2697480"/>
-            <a:ext cx="2514600" cy="868680"/>
-          </a:xfrm>
-          <a:prstGeom prst="roundRect">
-            <a:avLst>
-              <a:gd name="adj" fmla="val 8000"/>
-            </a:avLst>
-          </a:prstGeom>
-          <a:solidFill>
-            <a:srgbClr val="FFFFFF"/>
-          </a:solidFill>
-          <a:ln w="12700">
-            <a:solidFill>
-              <a:srgbClr val="E2D8CC"/>
-            </a:solidFill>
-          </a:ln>
-          <a:effectLst/>
-        </p:spPr>
-        <p:style>
-          <a:lnRef idx="1">
-            <a:schemeClr val="accent1"/>
-          </a:lnRef>
-          <a:fillRef idx="3">
-            <a:schemeClr val="accent1"/>
-          </a:fillRef>
-          <a:effectRef idx="2">
-            <a:schemeClr val="accent1"/>
-          </a:effectRef>
-          <a:fontRef idx="minor">
-            <a:schemeClr val="lt1"/>
-          </a:fontRef>
-        </p:style>
-        <p:txBody>
-          <a:bodyPr rtlCol="0" anchor="ctr" wrap="square" lIns="54864" rIns="54864" tIns="18288" bIns="18288"/>
-          <a:lstStyle/>
-          <a:p>
-            <a:pPr algn="ctr"/>
-            <a:r>
-              <a:rPr sz="1050" b="1">
-                <a:solidFill>
-                  <a:srgbClr val="1C1C1E"/>
-                </a:solidFill>
-                <a:latin typeface="Segoe UI"/>
-              </a:rPr>
-              <a:t>PLANNING</a:t>
-            </a:r>
-          </a:p>
-          <a:p>
-            <a:pPr algn="ctr"/>
-            <a:r>
-              <a:rPr sz="850">
-                <a:solidFill>
-                  <a:srgbClr val="4A4A52"/>
-                </a:solidFill>
-                <a:latin typeface="Segoe UI"/>
-              </a:rPr>
-              <a:t>hypothesis + falsifier
-re-plan after every result</a:t>
-            </a:r>
-          </a:p>
-        </p:txBody>
-      </p:sp>
-      <p:sp>
-        <p:nvSpPr>
-          <p:cNvPr id="10" name="Rounded Rectangle 9"/>
-          <p:cNvSpPr/>
-          <p:nvPr/>
-        </p:nvSpPr>
-        <p:spPr>
-          <a:xfrm>
-            <a:off x="3611880" y="2697480"/>
-            <a:ext cx="2514600" cy="868680"/>
-          </a:xfrm>
-          <a:prstGeom prst="roundRect">
-            <a:avLst>
-              <a:gd name="adj" fmla="val 8000"/>
-            </a:avLst>
-          </a:prstGeom>
-          <a:solidFill>
-            <a:srgbClr val="FFFFFF"/>
-          </a:solidFill>
-          <a:ln w="25400">
-            <a:solidFill>
-              <a:srgbClr val="1C1C1E"/>
-            </a:solidFill>
-          </a:ln>
-          <a:effectLst/>
-        </p:spPr>
-        <p:style>
-          <a:lnRef idx="1">
-            <a:schemeClr val="accent1"/>
-          </a:lnRef>
-          <a:fillRef idx="3">
-            <a:schemeClr val="accent1"/>
-          </a:fillRef>
-          <a:effectRef idx="2">
-            <a:schemeClr val="accent1"/>
-          </a:effectRef>
-          <a:fontRef idx="minor">
-            <a:schemeClr val="lt1"/>
-          </a:fontRef>
-        </p:style>
-        <p:txBody>
-          <a:bodyPr rtlCol="0" anchor="ctr" wrap="square" lIns="54864" rIns="54864" tIns="18288" bIns="18288"/>
-          <a:lstStyle/>
-          <a:p>
-            <a:pPr algn="ctr"/>
-            <a:r>
-              <a:rPr sz="1050" b="1">
-                <a:solidFill>
-                  <a:srgbClr val="1C1C1E"/>
-                </a:solidFill>
-                <a:latin typeface="Segoe UI"/>
-              </a:rPr>
-              <a:t>AGENT / CONTROLLER</a:t>
-            </a:r>
-          </a:p>
-          <a:p>
-            <a:pPr algn="ctr"/>
-            <a:r>
-              <a:rPr sz="850">
-                <a:solidFill>
-                  <a:srgbClr val="4A4A52"/>
-                </a:solidFill>
-                <a:latin typeface="Segoe UI"/>
-              </a:rPr>
-              <a:t>Investigation · Case
-investigate() · reconsider()</a:t>
-            </a:r>
-          </a:p>
-        </p:txBody>
-      </p:sp>
-      <p:sp>
-        <p:nvSpPr>
-          <p:cNvPr id="11" name="Rounded Rectangle 10"/>
-          <p:cNvSpPr/>
-          <p:nvPr/>
-        </p:nvSpPr>
-        <p:spPr>
-          <a:xfrm>
-            <a:off x="6446520" y="2697480"/>
-            <a:ext cx="2514600" cy="868680"/>
-          </a:xfrm>
-          <a:prstGeom prst="roundRect">
-            <a:avLst>
-              <a:gd name="adj" fmla="val 8000"/>
-            </a:avLst>
-          </a:prstGeom>
-          <a:solidFill>
-            <a:srgbClr val="FFFFFF"/>
-          </a:solidFill>
-          <a:ln w="12700">
-            <a:solidFill>
-              <a:srgbClr val="E2D8CC"/>
-            </a:solidFill>
-          </a:ln>
-          <a:effectLst/>
-        </p:spPr>
-        <p:style>
-          <a:lnRef idx="1">
-            <a:schemeClr val="accent1"/>
-          </a:lnRef>
-          <a:fillRef idx="3">
-            <a:schemeClr val="accent1"/>
-          </a:fillRef>
-          <a:effectRef idx="2">
-            <a:schemeClr val="accent1"/>
-          </a:effectRef>
-          <a:fontRef idx="minor">
-            <a:schemeClr val="lt1"/>
-          </a:fontRef>
-        </p:style>
-        <p:txBody>
-          <a:bodyPr rtlCol="0" anchor="ctr" wrap="square" lIns="54864" rIns="54864" tIns="18288" bIns="18288"/>
-          <a:lstStyle/>
-          <a:p>
-            <a:pPr algn="ctr"/>
-            <a:r>
-              <a:rPr sz="1050" b="1">
-                <a:solidFill>
-                  <a:srgbClr val="1C1C1E"/>
-                </a:solidFill>
-                <a:latin typeface="Segoe UI"/>
-              </a:rPr>
-              <a:t>MEMORY / STATE</a:t>
-            </a:r>
-          </a:p>
-          <a:p>
-            <a:pPr algn="ctr"/>
-            <a:r>
-              <a:rPr sz="850">
-                <a:solidFill>
-                  <a:srgbClr val="4A4A52"/>
-                </a:solidFill>
-                <a:latin typeface="Segoe UI"/>
-              </a:rPr>
-              <a:t>trace · cases.json
-conclusions append-only</a:t>
-            </a:r>
-          </a:p>
-        </p:txBody>
-      </p:sp>
-      <p:sp>
-        <p:nvSpPr>
-          <p:cNvPr id="12" name="Rounded Rectangle 11"/>
-          <p:cNvSpPr/>
-          <p:nvPr/>
-        </p:nvSpPr>
-        <p:spPr>
-          <a:xfrm>
-            <a:off x="9281160" y="2697480"/>
-            <a:ext cx="2103120" cy="868680"/>
-          </a:xfrm>
-          <a:prstGeom prst="roundRect">
-            <a:avLst>
-              <a:gd name="adj" fmla="val 8000"/>
-            </a:avLst>
-          </a:prstGeom>
-          <a:solidFill>
-            <a:srgbClr val="E8F6EF"/>
-          </a:solidFill>
-          <a:ln w="12700">
-            <a:solidFill>
-              <a:srgbClr val="0B6B44"/>
-            </a:solidFill>
-          </a:ln>
-          <a:effectLst/>
-        </p:spPr>
-        <p:style>
-          <a:lnRef idx="1">
-            <a:schemeClr val="accent1"/>
-          </a:lnRef>
-          <a:fillRef idx="3">
-            <a:schemeClr val="accent1"/>
-          </a:fillRef>
-          <a:effectRef idx="2">
-            <a:schemeClr val="accent1"/>
-          </a:effectRef>
-          <a:fontRef idx="minor">
-            <a:schemeClr val="lt1"/>
-          </a:fontRef>
-        </p:style>
-        <p:txBody>
-          <a:bodyPr rtlCol="0" anchor="ctr" wrap="square" lIns="54864" rIns="54864" tIns="18288" bIns="18288"/>
-          <a:lstStyle/>
-          <a:p>
-            <a:pPr algn="ctr"/>
-            <a:r>
-              <a:rPr sz="1050" b="1">
-                <a:solidFill>
-                  <a:srgbClr val="0B6B44"/>
-                </a:solidFill>
-                <a:latin typeface="Segoe UI"/>
-              </a:rPr>
-              <a:t>HUMAN INTERACTION</a:t>
-            </a:r>
-          </a:p>
-          <a:p>
-            <a:pPr algn="ctr"/>
-            <a:r>
-              <a:rPr sz="850">
-                <a:solidFill>
-                  <a:srgbClr val="4A4A52"/>
-                </a:solidFill>
-                <a:latin typeface="Segoe UI"/>
-              </a:rPr>
-              <a:t>human_override()
-inject_new_evidence()</a:t>
-            </a:r>
-          </a:p>
-        </p:txBody>
-      </p:sp>
-      <p:sp>
-        <p:nvSpPr>
-          <p:cNvPr id="13" name="Rounded Rectangle 12"/>
-          <p:cNvSpPr/>
-          <p:nvPr/>
-        </p:nvSpPr>
-        <p:spPr>
-          <a:xfrm>
-            <a:off x="777240" y="3931920"/>
-            <a:ext cx="8183879" cy="1170432"/>
-          </a:xfrm>
-          <a:prstGeom prst="roundRect">
-            <a:avLst>
-              <a:gd name="adj" fmla="val 7000"/>
-            </a:avLst>
-          </a:prstGeom>
-          <a:solidFill>
-            <a:srgbClr val="FAF5EE"/>
-          </a:solidFill>
-          <a:ln>
-            <a:solidFill>
-              <a:srgbClr val="E2D8CC"/>
-            </a:solidFill>
-          </a:ln>
-          <a:effectLst/>
-        </p:spPr>
-        <p:style>
-          <a:lnRef idx="1">
-            <a:schemeClr val="accent1"/>
-          </a:lnRef>
-          <a:fillRef idx="3">
-            <a:schemeClr val="accent1"/>
-          </a:fillRef>
-          <a:effectRef idx="2">
-            <a:schemeClr val="accent1"/>
-          </a:effectRef>
-          <a:fontRef idx="minor">
-            <a:schemeClr val="lt1"/>
-          </a:fontRef>
-        </p:style>
-        <p:txBody>
-          <a:bodyPr rtlCol="0" anchor="ctr"/>
-          <a:lstStyle/>
-          <a:p>
-            <a:pPr algn="ctr"/>
-          </a:p>
-        </p:txBody>
-      </p:sp>
-      <p:sp>
-        <p:nvSpPr>
-          <p:cNvPr id="14" name="TextBox 13"/>
-          <p:cNvSpPr txBox="1"/>
-          <p:nvPr/>
-        </p:nvSpPr>
-        <p:spPr>
-          <a:xfrm>
-            <a:off x="932688" y="3977639"/>
-            <a:ext cx="3657600" cy="201168"/>
-          </a:xfrm>
-          <a:prstGeom prst="rect">
-            <a:avLst/>
-          </a:prstGeom>
-          <a:noFill/>
-        </p:spPr>
-        <p:txBody>
-          <a:bodyPr wrap="square" lIns="0" rIns="0" tIns="0" bIns="0">
-            <a:spAutoFit/>
-          </a:bodyPr>
-          <a:lstStyle/>
-          <a:p>
-            <a:pPr algn="l">
-              <a:lnSpc>
-                <a:spcPct val="125000"/>
-              </a:lnSpc>
-              <a:spcAft>
-                <a:spcPts val="600"/>
-              </a:spcAft>
-            </a:pPr>
-            <a:r>
-              <a:rPr sz="900" b="1">
-                <a:solidFill>
-                  <a:srgbClr val="8A8A94"/>
-                </a:solidFill>
-                <a:latin typeface="Segoe UI"/>
-              </a:rPr>
-              <a:t>TOOL BUS · the one entry point</a:t>
-            </a:r>
-          </a:p>
-        </p:txBody>
-      </p:sp>
-      <p:sp>
-        <p:nvSpPr>
-          <p:cNvPr id="15" name="Rounded Rectangle 14"/>
-          <p:cNvSpPr/>
-          <p:nvPr/>
-        </p:nvSpPr>
-        <p:spPr>
-          <a:xfrm>
-            <a:off x="932688" y="4224528"/>
-            <a:ext cx="2487168" cy="786384"/>
-          </a:xfrm>
-          <a:prstGeom prst="roundRect">
-            <a:avLst>
-              <a:gd name="adj" fmla="val 8000"/>
-            </a:avLst>
-          </a:prstGeom>
-          <a:solidFill>
-            <a:srgbClr val="FFFFFF"/>
-          </a:solidFill>
-          <a:ln w="12700">
-            <a:solidFill>
-              <a:srgbClr val="E2D8CC"/>
-            </a:solidFill>
-          </a:ln>
-          <a:effectLst/>
-        </p:spPr>
-        <p:style>
-          <a:lnRef idx="1">
-            <a:schemeClr val="accent1"/>
-          </a:lnRef>
-          <a:fillRef idx="3">
-            <a:schemeClr val="accent1"/>
-          </a:fillRef>
-          <a:effectRef idx="2">
-            <a:schemeClr val="accent1"/>
-          </a:effectRef>
-          <a:fontRef idx="minor">
-            <a:schemeClr val="lt1"/>
-          </a:fontRef>
-        </p:style>
-        <p:txBody>
-          <a:bodyPr rtlCol="0" anchor="ctr" wrap="square" lIns="54864" rIns="54864" tIns="18288" bIns="18288"/>
-          <a:lstStyle/>
-          <a:p>
-            <a:pPr algn="ctr"/>
-            <a:r>
-              <a:rPr sz="1050" b="1">
-                <a:solidFill>
-                  <a:srgbClr val="1C1C1E"/>
-                </a:solidFill>
-                <a:latin typeface="Segoe UI"/>
-              </a:rPr>
-              <a:t>RETRIEVAL</a:t>
-            </a:r>
-          </a:p>
-          <a:p>
-            <a:pPr algn="ctr"/>
-            <a:r>
-              <a:rPr sz="850">
-                <a:solidFill>
-                  <a:srgbClr val="4A4A52"/>
-                </a:solidFill>
-                <a:latin typeface="Segoe UI"/>
-              </a:rPr>
-              <a:t>8 read tools, keyed lookup
-+ stored case verdicts</a:t>
-            </a:r>
-          </a:p>
-        </p:txBody>
-      </p:sp>
-      <p:sp>
-        <p:nvSpPr>
-          <p:cNvPr id="16" name="Rounded Rectangle 15"/>
-          <p:cNvSpPr/>
-          <p:nvPr/>
-        </p:nvSpPr>
-        <p:spPr>
-          <a:xfrm>
-            <a:off x="3566160" y="4224528"/>
-            <a:ext cx="2487168" cy="786384"/>
-          </a:xfrm>
-          <a:prstGeom prst="roundRect">
-            <a:avLst>
-              <a:gd name="adj" fmla="val 8000"/>
-            </a:avLst>
-          </a:prstGeom>
-          <a:solidFill>
-            <a:srgbClr val="FFFFFF"/>
-          </a:solidFill>
-          <a:ln w="12700">
-            <a:solidFill>
-              <a:srgbClr val="E2D8CC"/>
-            </a:solidFill>
-          </a:ln>
-          <a:effectLst/>
-        </p:spPr>
-        <p:style>
-          <a:lnRef idx="1">
-            <a:schemeClr val="accent1"/>
-          </a:lnRef>
-          <a:fillRef idx="3">
-            <a:schemeClr val="accent1"/>
-          </a:fillRef>
-          <a:effectRef idx="2">
-            <a:schemeClr val="accent1"/>
-          </a:effectRef>
-          <a:fontRef idx="minor">
-            <a:schemeClr val="lt1"/>
-          </a:fontRef>
-        </p:style>
-        <p:txBody>
-          <a:bodyPr rtlCol="0" anchor="ctr" wrap="square" lIns="54864" rIns="54864" tIns="18288" bIns="18288"/>
-          <a:lstStyle/>
-          <a:p>
-            <a:pPr algn="ctr"/>
-            <a:r>
-              <a:rPr sz="1050" b="1">
-                <a:solidFill>
-                  <a:srgbClr val="1C1C1E"/>
-                </a:solidFill>
-                <a:latin typeface="Segoe UI"/>
-              </a:rPr>
-              <a:t>TOOLS</a:t>
-            </a:r>
-          </a:p>
-          <a:p>
-            <a:pPr algn="ctr"/>
-            <a:r>
-              <a:rPr sz="850">
-                <a:solidFill>
-                  <a:srgbClr val="4A4A52"/>
-                </a:solidFill>
-                <a:latin typeface="Segoe UI"/>
-              </a:rPr>
-              <a:t>block_ip · unblock_ip
-submit_assessment</a:t>
-            </a:r>
-          </a:p>
-        </p:txBody>
-      </p:sp>
-      <p:sp>
-        <p:nvSpPr>
-          <p:cNvPr id="17" name="Rounded Rectangle 16"/>
-          <p:cNvSpPr/>
-          <p:nvPr/>
-        </p:nvSpPr>
-        <p:spPr>
-          <a:xfrm>
-            <a:off x="6199632" y="4224528"/>
-            <a:ext cx="2624328" cy="786384"/>
-          </a:xfrm>
-          <a:prstGeom prst="roundRect">
-            <a:avLst>
-              <a:gd name="adj" fmla="val 8000"/>
-            </a:avLst>
-          </a:prstGeom>
-          <a:solidFill>
-            <a:srgbClr val="FFFFFF"/>
-          </a:solidFill>
-          <a:ln w="12700">
-            <a:solidFill>
-              <a:srgbClr val="E2551F"/>
-            </a:solidFill>
-          </a:ln>
-          <a:effectLst/>
-        </p:spPr>
-        <p:style>
-          <a:lnRef idx="1">
-            <a:schemeClr val="accent1"/>
-          </a:lnRef>
-          <a:fillRef idx="3">
-            <a:schemeClr val="accent1"/>
-          </a:fillRef>
-          <a:effectRef idx="2">
-            <a:schemeClr val="accent1"/>
-          </a:effectRef>
-          <a:fontRef idx="minor">
-            <a:schemeClr val="lt1"/>
-          </a:fontRef>
-        </p:style>
-        <p:txBody>
-          <a:bodyPr rtlCol="0" anchor="ctr" wrap="square" lIns="54864" rIns="54864" tIns="18288" bIns="18288"/>
-          <a:lstStyle/>
-          <a:p>
-            <a:pPr algn="ctr"/>
-            <a:r>
-              <a:rPr sz="1050" b="1">
-                <a:solidFill>
-                  <a:srgbClr val="E2551F"/>
-                </a:solidFill>
-                <a:latin typeface="Segoe UI"/>
-              </a:rPr>
-              <a:t>FAILURE HANDLING</a:t>
-            </a:r>
-          </a:p>
-          <a:p>
-            <a:pPr algn="ctr"/>
-            <a:r>
-              <a:rPr sz="850">
-                <a:solidFill>
-                  <a:srgbClr val="4A4A52"/>
-                </a:solidFill>
-                <a:latin typeface="Segoe UI"/>
-              </a:rPr>
-              <a:t>retry · degraded clamp
-refusal · impasse after 3</a:t>
-            </a:r>
-          </a:p>
-        </p:txBody>
-      </p:sp>
-      <p:sp>
-        <p:nvSpPr>
-          <p:cNvPr id="18" name="Rounded Rectangle 17"/>
-          <p:cNvSpPr/>
-          <p:nvPr/>
-        </p:nvSpPr>
-        <p:spPr>
-          <a:xfrm>
-            <a:off x="9281160" y="3931920"/>
-            <a:ext cx="2103120" cy="1170432"/>
-          </a:xfrm>
-          <a:prstGeom prst="roundRect">
-            <a:avLst>
-              <a:gd name="adj" fmla="val 8000"/>
-            </a:avLst>
-          </a:prstGeom>
-          <a:solidFill>
-            <a:srgbClr val="FFE8DC"/>
-          </a:solidFill>
-          <a:ln w="25400">
-            <a:solidFill>
-              <a:srgbClr val="E2551F"/>
-            </a:solidFill>
-          </a:ln>
-          <a:effectLst/>
-        </p:spPr>
-        <p:style>
-          <a:lnRef idx="1">
-            <a:schemeClr val="accent1"/>
-          </a:lnRef>
-          <a:fillRef idx="3">
-            <a:schemeClr val="accent1"/>
-          </a:fillRef>
-          <a:effectRef idx="2">
-            <a:schemeClr val="accent1"/>
-          </a:effectRef>
-          <a:fontRef idx="minor">
-            <a:schemeClr val="lt1"/>
-          </a:fontRef>
-        </p:style>
-        <p:txBody>
-          <a:bodyPr rtlCol="0" anchor="ctr" wrap="square" lIns="54864" rIns="54864" tIns="18288" bIns="18288"/>
-          <a:lstStyle/>
-          <a:p>
-            <a:pPr algn="ctr"/>
-            <a:r>
-              <a:rPr sz="1050" b="1">
-                <a:solidFill>
-                  <a:srgbClr val="E2551F"/>
-                </a:solidFill>
-                <a:latin typeface="Segoe UI"/>
-              </a:rPr>
-              <a:t>EVALUATION /
-VERIFICATION</a:t>
-            </a:r>
-          </a:p>
-          <a:p>
-            <a:pPr algn="ctr"/>
-            <a:r>
-              <a:rPr sz="850">
-                <a:solidFill>
-                  <a:srgbClr val="4A4A52"/>
-                </a:solidFill>
-                <a:latin typeface="Segoe UI"/>
-              </a:rPr>
-              <a:t>4 guard families
-score() · re-read from disk</a:t>
-            </a:r>
-          </a:p>
-        </p:txBody>
-      </p:sp>
-      <p:cxnSp>
-        <p:nvCxnSpPr>
-          <p:cNvPr id="19" name="Connector 18"/>
-          <p:cNvCxnSpPr/>
-          <p:nvPr/>
-        </p:nvCxnSpPr>
-        <p:spPr>
-          <a:xfrm flipH="1">
-            <a:off x="3291840" y="3131820"/>
-            <a:ext cx="320040" cy="0"/>
-          </a:xfrm>
-          <a:prstGeom prst="line">
-            <a:avLst/>
-          </a:prstGeom>
-          <a:ln w="17780">
-            <a:solidFill>
-              <a:srgbClr val="8A8A94"/>
-            </a:solidFill>
-            <a:tailEnd type="triangle" w="med" len="med"/>
-          </a:ln>
-        </p:spPr>
-        <p:style>
-          <a:lnRef idx="2">
-            <a:schemeClr val="accent1"/>
-          </a:lnRef>
-          <a:fillRef idx="0">
-            <a:schemeClr val="accent1"/>
-          </a:fillRef>
-          <a:effectRef idx="1">
-            <a:schemeClr val="accent1"/>
-          </a:effectRef>
-          <a:fontRef idx="minor">
-            <a:schemeClr val="tx1"/>
-          </a:fontRef>
-        </p:style>
-      </p:cxnSp>
-      <p:cxnSp>
-        <p:nvCxnSpPr>
-          <p:cNvPr id="20" name="Connector 19"/>
-          <p:cNvCxnSpPr/>
-          <p:nvPr/>
-        </p:nvCxnSpPr>
-        <p:spPr>
-          <a:xfrm>
-            <a:off x="6126480" y="3131820"/>
-            <a:ext cx="320040" cy="0"/>
-          </a:xfrm>
-          <a:prstGeom prst="line">
-            <a:avLst/>
-          </a:prstGeom>
-          <a:ln w="17780">
-            <a:solidFill>
-              <a:srgbClr val="8A8A94"/>
-            </a:solidFill>
-            <a:tailEnd type="triangle" w="med" len="med"/>
-          </a:ln>
-        </p:spPr>
-        <p:style>
-          <a:lnRef idx="2">
-            <a:schemeClr val="accent1"/>
-          </a:lnRef>
-          <a:fillRef idx="0">
-            <a:schemeClr val="accent1"/>
-          </a:fillRef>
-          <a:effectRef idx="1">
-            <a:schemeClr val="accent1"/>
-          </a:effectRef>
-          <a:fontRef idx="minor">
-            <a:schemeClr val="tx1"/>
-          </a:fontRef>
-        </p:style>
-      </p:cxnSp>
-      <p:cxnSp>
-        <p:nvCxnSpPr>
-          <p:cNvPr id="21" name="Connector 20"/>
-          <p:cNvCxnSpPr/>
-          <p:nvPr/>
-        </p:nvCxnSpPr>
-        <p:spPr>
-          <a:xfrm>
-            <a:off x="2011680" y="3566160"/>
-            <a:ext cx="0" cy="365760"/>
-          </a:xfrm>
-          <a:prstGeom prst="line">
-            <a:avLst/>
-          </a:prstGeom>
-          <a:ln w="17780">
-            <a:solidFill>
-              <a:srgbClr val="8A8A94"/>
-            </a:solidFill>
-            <a:tailEnd type="triangle" w="med" len="med"/>
-          </a:ln>
-        </p:spPr>
-        <p:style>
-          <a:lnRef idx="2">
-            <a:schemeClr val="accent1"/>
-          </a:lnRef>
-          <a:fillRef idx="0">
-            <a:schemeClr val="accent1"/>
-          </a:fillRef>
-          <a:effectRef idx="1">
-            <a:schemeClr val="accent1"/>
-          </a:effectRef>
-          <a:fontRef idx="minor">
-            <a:schemeClr val="tx1"/>
-          </a:fontRef>
-        </p:style>
-      </p:cxnSp>
-      <p:cxnSp>
-        <p:nvCxnSpPr>
-          <p:cNvPr id="22" name="Connector 21"/>
-          <p:cNvCxnSpPr/>
-          <p:nvPr/>
-        </p:nvCxnSpPr>
-        <p:spPr>
-          <a:xfrm flipV="1">
-            <a:off x="3456432" y="2340864"/>
-            <a:ext cx="0" cy="1591056"/>
-          </a:xfrm>
-          <a:prstGeom prst="line">
-            <a:avLst/>
-          </a:prstGeom>
-          <a:ln w="17780">
-            <a:solidFill>
-              <a:srgbClr val="E2551F"/>
-            </a:solidFill>
-            <a:prstDash val="dash"/>
-            <a:tailEnd type="triangle" w="med" len="med"/>
-          </a:ln>
-        </p:spPr>
-        <p:style>
-          <a:lnRef idx="2">
-            <a:schemeClr val="accent1"/>
-          </a:lnRef>
-          <a:fillRef idx="0">
-            <a:schemeClr val="accent1"/>
-          </a:fillRef>
-          <a:effectRef idx="1">
-            <a:schemeClr val="accent1"/>
-          </a:effectRef>
-          <a:fontRef idx="minor">
-            <a:schemeClr val="tx1"/>
-          </a:fontRef>
-        </p:style>
-      </p:cxnSp>
-      <p:cxnSp>
-        <p:nvCxnSpPr>
-          <p:cNvPr id="23" name="Connector 22"/>
-          <p:cNvCxnSpPr/>
-          <p:nvPr/>
-        </p:nvCxnSpPr>
-        <p:spPr>
-          <a:xfrm flipV="1">
-            <a:off x="10332720" y="2523744"/>
-            <a:ext cx="0" cy="173736"/>
-          </a:xfrm>
-          <a:prstGeom prst="line">
-            <a:avLst/>
-          </a:prstGeom>
-          <a:ln w="17780">
-            <a:solidFill>
-              <a:srgbClr val="0B6B44"/>
-            </a:solidFill>
-          </a:ln>
-        </p:spPr>
-        <p:style>
-          <a:lnRef idx="2">
-            <a:schemeClr val="accent1"/>
-          </a:lnRef>
-          <a:fillRef idx="0">
-            <a:schemeClr val="accent1"/>
-          </a:fillRef>
-          <a:effectRef idx="1">
-            <a:schemeClr val="accent1"/>
-          </a:effectRef>
-          <a:fontRef idx="minor">
-            <a:schemeClr val="tx1"/>
-          </a:fontRef>
-        </p:style>
-      </p:cxnSp>
-      <p:cxnSp>
-        <p:nvCxnSpPr>
-          <p:cNvPr id="24" name="Connector 23"/>
-          <p:cNvCxnSpPr/>
-          <p:nvPr/>
-        </p:nvCxnSpPr>
-        <p:spPr>
-          <a:xfrm flipH="1">
-            <a:off x="5143500" y="2523744"/>
-            <a:ext cx="5189220" cy="0"/>
-          </a:xfrm>
-          <a:prstGeom prst="line">
-            <a:avLst/>
-          </a:prstGeom>
-          <a:ln w="17780">
-            <a:solidFill>
-              <a:srgbClr val="0B6B44"/>
-            </a:solidFill>
-          </a:ln>
-        </p:spPr>
-        <p:style>
-          <a:lnRef idx="2">
-            <a:schemeClr val="accent1"/>
-          </a:lnRef>
-          <a:fillRef idx="0">
-            <a:schemeClr val="accent1"/>
-          </a:fillRef>
-          <a:effectRef idx="1">
-            <a:schemeClr val="accent1"/>
-          </a:effectRef>
-          <a:fontRef idx="minor">
-            <a:schemeClr val="tx1"/>
-          </a:fontRef>
-        </p:style>
-      </p:cxnSp>
-      <p:cxnSp>
-        <p:nvCxnSpPr>
-          <p:cNvPr id="25" name="Connector 24"/>
-          <p:cNvCxnSpPr/>
-          <p:nvPr/>
-        </p:nvCxnSpPr>
-        <p:spPr>
-          <a:xfrm>
-            <a:off x="5143500" y="2523744"/>
-            <a:ext cx="0" cy="173736"/>
-          </a:xfrm>
-          <a:prstGeom prst="line">
-            <a:avLst/>
-          </a:prstGeom>
-          <a:ln w="17780">
-            <a:solidFill>
-              <a:srgbClr val="0B6B44"/>
-            </a:solidFill>
-            <a:tailEnd type="triangle" w="med" len="med"/>
-          </a:ln>
-        </p:spPr>
-        <p:style>
-          <a:lnRef idx="2">
-            <a:schemeClr val="accent1"/>
-          </a:lnRef>
-          <a:fillRef idx="0">
-            <a:schemeClr val="accent1"/>
-          </a:fillRef>
-          <a:effectRef idx="1">
-            <a:schemeClr val="accent1"/>
-          </a:effectRef>
-          <a:fontRef idx="minor">
-            <a:schemeClr val="tx1"/>
-          </a:fontRef>
-        </p:style>
-      </p:cxnSp>
-      <p:cxnSp>
-        <p:nvCxnSpPr>
-          <p:cNvPr id="26" name="Connector 25"/>
-          <p:cNvCxnSpPr/>
-          <p:nvPr/>
-        </p:nvCxnSpPr>
-        <p:spPr>
-          <a:xfrm>
-            <a:off x="8961120" y="4617720"/>
-            <a:ext cx="320040" cy="0"/>
-          </a:xfrm>
-          <a:prstGeom prst="line">
-            <a:avLst/>
-          </a:prstGeom>
-          <a:ln w="17780">
-            <a:solidFill>
-              <a:srgbClr val="E2551F"/>
-            </a:solidFill>
-            <a:tailEnd type="triangle" w="med" len="med"/>
-          </a:ln>
-        </p:spPr>
-        <p:style>
-          <a:lnRef idx="2">
-            <a:schemeClr val="accent1"/>
-          </a:lnRef>
-          <a:fillRef idx="0">
-            <a:schemeClr val="accent1"/>
-          </a:fillRef>
-          <a:effectRef idx="1">
-            <a:schemeClr val="accent1"/>
-          </a:effectRef>
-          <a:fontRef idx="minor">
-            <a:schemeClr val="tx1"/>
-          </a:fontRef>
-        </p:style>
-      </p:cxnSp>
-      <p:cxnSp>
-        <p:nvCxnSpPr>
-          <p:cNvPr id="27" name="Connector 26"/>
-          <p:cNvCxnSpPr/>
-          <p:nvPr/>
-        </p:nvCxnSpPr>
-        <p:spPr>
-          <a:xfrm flipV="1">
-            <a:off x="9692640" y="3749039"/>
-            <a:ext cx="0" cy="182881"/>
-          </a:xfrm>
-          <a:prstGeom prst="line">
-            <a:avLst/>
-          </a:prstGeom>
-          <a:ln w="17780">
-            <a:solidFill>
-              <a:srgbClr val="E2551F"/>
-            </a:solidFill>
-          </a:ln>
-        </p:spPr>
-        <p:style>
-          <a:lnRef idx="2">
-            <a:schemeClr val="accent1"/>
-          </a:lnRef>
-          <a:fillRef idx="0">
-            <a:schemeClr val="accent1"/>
-          </a:fillRef>
-          <a:effectRef idx="1">
-            <a:schemeClr val="accent1"/>
-          </a:effectRef>
-          <a:fontRef idx="minor">
-            <a:schemeClr val="tx1"/>
-          </a:fontRef>
-        </p:style>
-      </p:cxnSp>
-      <p:cxnSp>
-        <p:nvCxnSpPr>
-          <p:cNvPr id="28" name="Connector 27"/>
-          <p:cNvCxnSpPr/>
-          <p:nvPr/>
-        </p:nvCxnSpPr>
-        <p:spPr>
-          <a:xfrm flipH="1">
-            <a:off x="4594860" y="3749039"/>
-            <a:ext cx="5097780" cy="0"/>
-          </a:xfrm>
-          <a:prstGeom prst="line">
-            <a:avLst/>
-          </a:prstGeom>
-          <a:ln w="17780">
-            <a:solidFill>
-              <a:srgbClr val="E2551F"/>
-            </a:solidFill>
-          </a:ln>
-        </p:spPr>
-        <p:style>
-          <a:lnRef idx="2">
-            <a:schemeClr val="accent1"/>
-          </a:lnRef>
-          <a:fillRef idx="0">
-            <a:schemeClr val="accent1"/>
-          </a:fillRef>
-          <a:effectRef idx="1">
-            <a:schemeClr val="accent1"/>
-          </a:effectRef>
-          <a:fontRef idx="minor">
-            <a:schemeClr val="tx1"/>
-          </a:fontRef>
-        </p:style>
-      </p:cxnSp>
-      <p:cxnSp>
-        <p:nvCxnSpPr>
-          <p:cNvPr id="29" name="Connector 28"/>
-          <p:cNvCxnSpPr/>
-          <p:nvPr/>
-        </p:nvCxnSpPr>
-        <p:spPr>
-          <a:xfrm flipV="1">
-            <a:off x="4594860" y="3566160"/>
-            <a:ext cx="0" cy="182879"/>
-          </a:xfrm>
-          <a:prstGeom prst="line">
-            <a:avLst/>
-          </a:prstGeom>
-          <a:ln w="17780">
-            <a:solidFill>
-              <a:srgbClr val="E2551F"/>
-            </a:solidFill>
-            <a:tailEnd type="triangle" w="med" len="med"/>
-          </a:ln>
-        </p:spPr>
-        <p:style>
-          <a:lnRef idx="2">
-            <a:schemeClr val="accent1"/>
-          </a:lnRef>
-          <a:fillRef idx="0">
-            <a:schemeClr val="accent1"/>
-          </a:fillRef>
-          <a:effectRef idx="1">
-            <a:schemeClr val="accent1"/>
-          </a:effectRef>
-          <a:fontRef idx="minor">
-            <a:schemeClr val="tx1"/>
-          </a:fontRef>
-        </p:style>
-      </p:cxnSp>
-      <p:sp>
-        <p:nvSpPr>
-          <p:cNvPr id="30" name="TextBox 29"/>
-          <p:cNvSpPr txBox="1"/>
-          <p:nvPr/>
-        </p:nvSpPr>
-        <p:spPr>
-          <a:xfrm>
-            <a:off x="777240" y="5349240"/>
-            <a:ext cx="10607040" cy="320040"/>
-          </a:xfrm>
-          <a:prstGeom prst="rect">
-            <a:avLst/>
-          </a:prstGeom>
-          <a:noFill/>
-        </p:spPr>
-        <p:txBody>
-          <a:bodyPr wrap="square" lIns="0" rIns="0" tIns="0" bIns="0">
-            <a:spAutoFit/>
-          </a:bodyPr>
-          <a:lstStyle/>
-          <a:p>
-            <a:pPr algn="l">
-              <a:lnSpc>
-                <a:spcPct val="125000"/>
-              </a:lnSpc>
-              <a:spcAft>
-                <a:spcPts val="600"/>
-              </a:spcAft>
-            </a:pPr>
-            <a:r>
-              <a:rPr sz="1200" b="1">
-                <a:solidFill>
-                  <a:srgbClr val="E2551F"/>
-                </a:solidFill>
-                <a:latin typeface="Segoe UI"/>
-              </a:rPr>
-              <a:t>reconsider() re-enters at HYPOTHESIZE, not at the verdict: evidence, failure and override all route through it.</a:t>
-            </a:r>
-          </a:p>
-        </p:txBody>
-      </p:sp>
-      <p:sp>
-        <p:nvSpPr>
-          <p:cNvPr id="31" name="TextBox 30"/>
-          <p:cNvSpPr txBox="1"/>
-          <p:nvPr/>
-        </p:nvSpPr>
-        <p:spPr>
-          <a:xfrm>
-            <a:off x="777240" y="5742432"/>
-            <a:ext cx="10607040" cy="548640"/>
-          </a:xfrm>
-          <a:prstGeom prst="rect">
-            <a:avLst/>
-          </a:prstGeom>
-          <a:noFill/>
-        </p:spPr>
-        <p:txBody>
-          <a:bodyPr wrap="square" lIns="0" rIns="0" tIns="0" bIns="0">
-            <a:spAutoFit/>
-          </a:bodyPr>
-          <a:lstStyle/>
-          <a:p>
-            <a:pPr algn="l">
-              <a:lnSpc>
-                <a:spcPct val="125000"/>
-              </a:lnSpc>
-              <a:spcAft>
-                <a:spcPts val="600"/>
-              </a:spcAft>
-            </a:pPr>
-            <a:r>
-              <a:rPr sz="1200" b="0">
-                <a:solidFill>
-                  <a:srgbClr val="4A4A52"/>
-                </a:solidFill>
-                <a:latin typeface="Segoe UI"/>
-              </a:rPr>
-              <a:t>The model decides which tool, in what order, and what the evidence means. Code decides whether a claim is well-formed, the score, and the action policy. Nothing reaches a real network, host or credential.</a:t>
-            </a:r>
-          </a:p>
-        </p:txBody>
-      </p:sp>
-      <p:sp>
-        <p:nvSpPr>
-          <p:cNvPr id="32" name="TextBox 31"/>
-          <p:cNvSpPr txBox="1"/>
-          <p:nvPr/>
-        </p:nvSpPr>
-        <p:spPr>
-          <a:xfrm>
-            <a:off x="777240" y="6355080"/>
+            <a:off x="777240" y="6510528"/>
             <a:ext cx="10607040" cy="274320"/>
           </a:xfrm>
           <a:prstGeom prst="rect">
@@ -8811,7 +7575,7 @@
           </a:bodyPr>
           <a:lstStyle/>
           <a:p>
-            <a:pPr algn="l">
+            <a:pPr algn="r">
               <a:lnSpc>
                 <a:spcPct val="125000"/>
               </a:lnSpc>
@@ -10780,7 +9544,7 @@
                 </a:solidFill>
                 <a:latin typeface="Segoe UI"/>
               </a:rPr>
-              <a:t>"I need to fix two issues. Let me check openssh CVEs and remove the related_alert_corroborates factor since no_data is not a finding."</a:t>
+              <a:t>"Good catch - I need to fix two issues. Let me check openssh CVEs and remove the related_alert_corroborates factor since no_data is not a finding."</a:t>
             </a:r>
           </a:p>
         </p:txBody>
@@ -12079,14 +10843,16 @@
             <a:ext cx="6858000" cy="4023360"/>
           </a:xfrm>
           <a:prstGeom prst="roundRect">
-            <a:avLst/>
+            <a:avLst>
+              <a:gd name="adj" fmla="val 4000"/>
+            </a:avLst>
           </a:prstGeom>
           <a:solidFill>
             <a:srgbClr val="0D0D0D"/>
           </a:solidFill>
-          <a:ln>
+          <a:ln w="12700">
             <a:solidFill>
-              <a:srgbClr val="333333"/>
+              <a:srgbClr val="E2D8CC"/>
             </a:solidFill>
           </a:ln>
           <a:effectLst/>
@@ -12113,2071 +10879,33 @@
           </a:p>
         </p:txBody>
       </p:sp>
-      <p:sp>
-        <p:nvSpPr>
-          <p:cNvPr id="7" name="Rectangle 6"/>
-          <p:cNvSpPr/>
-          <p:nvPr/>
-        </p:nvSpPr>
-        <p:spPr>
-          <a:xfrm>
-            <a:off x="777240" y="1737360"/>
-            <a:ext cx="1572768" cy="4023360"/>
-          </a:xfrm>
-          <a:prstGeom prst="rect">
-            <a:avLst/>
-          </a:prstGeom>
-          <a:solidFill>
-            <a:srgbClr val="080808"/>
-          </a:solidFill>
-          <a:ln>
-            <a:noFill/>
-          </a:ln>
-          <a:effectLst/>
-        </p:spPr>
-        <p:style>
-          <a:lnRef idx="1">
-            <a:schemeClr val="accent1"/>
-          </a:lnRef>
-          <a:fillRef idx="3">
-            <a:schemeClr val="accent1"/>
-          </a:fillRef>
-          <a:effectRef idx="2">
-            <a:schemeClr val="accent1"/>
-          </a:effectRef>
-          <a:fontRef idx="minor">
-            <a:schemeClr val="lt1"/>
-          </a:fontRef>
-        </p:style>
-        <p:txBody>
-          <a:bodyPr rtlCol="0" anchor="ctr"/>
-          <a:lstStyle/>
-          <a:p>
-            <a:pPr algn="ctr"/>
-          </a:p>
-        </p:txBody>
-      </p:sp>
-      <p:sp>
-        <p:nvSpPr>
-          <p:cNvPr id="8" name="TextBox 7"/>
-          <p:cNvSpPr txBox="1"/>
-          <p:nvPr/>
-        </p:nvSpPr>
-        <p:spPr>
-          <a:xfrm>
-            <a:off x="905256" y="1856232"/>
-            <a:ext cx="1371600" cy="182880"/>
-          </a:xfrm>
-          <a:prstGeom prst="rect">
-            <a:avLst/>
-          </a:prstGeom>
-          <a:noFill/>
-        </p:spPr>
-        <p:txBody>
-          <a:bodyPr wrap="square" lIns="0" rIns="0" tIns="0" bIns="0">
-            <a:spAutoFit/>
-          </a:bodyPr>
-          <a:lstStyle/>
-          <a:p>
-            <a:pPr algn="l">
-              <a:lnSpc>
-                <a:spcPct val="125000"/>
-              </a:lnSpc>
-              <a:spcAft>
-                <a:spcPts val="600"/>
-              </a:spcAft>
-            </a:pPr>
-            <a:r>
-              <a:rPr sz="850" b="1">
-                <a:solidFill>
-                  <a:srgbClr val="E4E4E7"/>
-                </a:solidFill>
-                <a:latin typeface="Segoe UI"/>
-              </a:rPr>
-              <a:t>SOC AGENT</a:t>
-            </a:r>
-          </a:p>
-        </p:txBody>
-      </p:sp>
-      <p:sp>
-        <p:nvSpPr>
-          <p:cNvPr id="9" name="TextBox 8"/>
-          <p:cNvSpPr txBox="1"/>
-          <p:nvPr/>
-        </p:nvSpPr>
-        <p:spPr>
-          <a:xfrm>
-            <a:off x="905256" y="2121408"/>
-            <a:ext cx="1371600" cy="164592"/>
-          </a:xfrm>
-          <a:prstGeom prst="rect">
-            <a:avLst/>
-          </a:prstGeom>
-          <a:noFill/>
-        </p:spPr>
-        <p:txBody>
-          <a:bodyPr wrap="square" lIns="0" rIns="0" tIns="0" bIns="0">
-            <a:spAutoFit/>
-          </a:bodyPr>
-          <a:lstStyle/>
-          <a:p>
-            <a:pPr algn="l">
-              <a:lnSpc>
-                <a:spcPct val="125000"/>
-              </a:lnSpc>
-              <a:spcAft>
-                <a:spcPts val="600"/>
-              </a:spcAft>
-            </a:pPr>
-            <a:r>
-              <a:rPr sz="650" b="1">
-                <a:solidFill>
-                  <a:srgbClr val="8A8A94"/>
-                </a:solidFill>
-                <a:latin typeface="Segoe UI"/>
-              </a:rPr>
-              <a:t>SCENARIOS</a:t>
-            </a:r>
-          </a:p>
-        </p:txBody>
-      </p:sp>
-      <p:sp>
-        <p:nvSpPr>
-          <p:cNvPr id="10" name="TextBox 9"/>
-          <p:cNvSpPr txBox="1"/>
-          <p:nvPr/>
-        </p:nvSpPr>
-        <p:spPr>
-          <a:xfrm>
-            <a:off x="923544" y="2340864"/>
-            <a:ext cx="960120" cy="182880"/>
-          </a:xfrm>
-          <a:prstGeom prst="rect">
-            <a:avLst/>
-          </a:prstGeom>
-          <a:noFill/>
-        </p:spPr>
-        <p:txBody>
-          <a:bodyPr wrap="square" lIns="0" rIns="0" tIns="0" bIns="0">
-            <a:spAutoFit/>
-          </a:bodyPr>
-          <a:lstStyle/>
-          <a:p>
-            <a:pPr algn="l">
-              <a:lnSpc>
-                <a:spcPct val="125000"/>
-              </a:lnSpc>
-              <a:spcAft>
-                <a:spcPts val="600"/>
-              </a:spcAft>
-            </a:pPr>
-            <a:r>
-              <a:rPr sz="700" b="0">
-                <a:solidFill>
-                  <a:srgbClr val="8A8A94"/>
-                </a:solidFill>
-                <a:latin typeface="Segoe UI"/>
-              </a:rPr>
-              <a:t>1 False alarm</a:t>
-            </a:r>
-          </a:p>
-        </p:txBody>
-      </p:sp>
-      <p:sp>
-        <p:nvSpPr>
-          <p:cNvPr id="11" name="TextBox 10"/>
-          <p:cNvSpPr txBox="1"/>
-          <p:nvPr/>
-        </p:nvSpPr>
-        <p:spPr>
-          <a:xfrm>
-            <a:off x="1911096" y="2340864"/>
-            <a:ext cx="329184" cy="182880"/>
-          </a:xfrm>
-          <a:prstGeom prst="rect">
-            <a:avLst/>
-          </a:prstGeom>
-          <a:noFill/>
-        </p:spPr>
-        <p:txBody>
-          <a:bodyPr wrap="square" lIns="0" rIns="0" tIns="0" bIns="0">
-            <a:spAutoFit/>
-          </a:bodyPr>
-          <a:lstStyle/>
-          <a:p>
-            <a:pPr algn="l">
-              <a:lnSpc>
-                <a:spcPct val="125000"/>
-              </a:lnSpc>
-              <a:spcAft>
-                <a:spcPts val="600"/>
-              </a:spcAft>
-            </a:pPr>
-            <a:r>
-              <a:rPr sz="600" b="1">
-                <a:solidFill>
-                  <a:srgbClr val="0B6B44"/>
-                </a:solidFill>
-                <a:latin typeface="Segoe UI"/>
-              </a:rPr>
-              <a:t>FAIL</a:t>
-            </a:r>
-          </a:p>
-        </p:txBody>
-      </p:sp>
-      <p:sp>
-        <p:nvSpPr>
-          <p:cNvPr id="12" name="Rounded Rectangle 11"/>
-          <p:cNvSpPr/>
-          <p:nvPr/>
-        </p:nvSpPr>
-        <p:spPr>
-          <a:xfrm>
-            <a:off x="850392" y="2596896"/>
-            <a:ext cx="1426464" cy="237744"/>
-          </a:xfrm>
-          <a:prstGeom prst="roundRect">
-            <a:avLst/>
-          </a:prstGeom>
-          <a:solidFill>
-            <a:srgbClr val="161616"/>
-          </a:solidFill>
-          <a:ln>
-            <a:solidFill>
-              <a:srgbClr val="333333"/>
-            </a:solidFill>
-          </a:ln>
-          <a:effectLst/>
-        </p:spPr>
-        <p:style>
-          <a:lnRef idx="1">
-            <a:schemeClr val="accent1"/>
-          </a:lnRef>
-          <a:fillRef idx="3">
-            <a:schemeClr val="accent1"/>
-          </a:fillRef>
-          <a:effectRef idx="2">
-            <a:schemeClr val="accent1"/>
-          </a:effectRef>
-          <a:fontRef idx="minor">
-            <a:schemeClr val="lt1"/>
-          </a:fontRef>
-        </p:style>
-        <p:txBody>
-          <a:bodyPr rtlCol="0" anchor="ctr"/>
-          <a:lstStyle/>
-          <a:p>
-            <a:pPr algn="ctr"/>
-          </a:p>
-        </p:txBody>
-      </p:sp>
-      <p:sp>
-        <p:nvSpPr>
-          <p:cNvPr id="13" name="TextBox 12"/>
-          <p:cNvSpPr txBox="1"/>
-          <p:nvPr/>
-        </p:nvSpPr>
-        <p:spPr>
-          <a:xfrm>
-            <a:off x="923544" y="2615184"/>
-            <a:ext cx="960120" cy="182880"/>
-          </a:xfrm>
-          <a:prstGeom prst="rect">
-            <a:avLst/>
-          </a:prstGeom>
-          <a:noFill/>
-        </p:spPr>
-        <p:txBody>
-          <a:bodyPr wrap="square" lIns="0" rIns="0" tIns="0" bIns="0">
-            <a:spAutoFit/>
-          </a:bodyPr>
-          <a:lstStyle/>
-          <a:p>
-            <a:pPr algn="l">
-              <a:lnSpc>
-                <a:spcPct val="125000"/>
-              </a:lnSpc>
-              <a:spcAft>
-                <a:spcPts val="600"/>
-              </a:spcAft>
-            </a:pPr>
-            <a:r>
-              <a:rPr sz="700" b="0">
-                <a:solidFill>
-                  <a:srgbClr val="E4E4E7"/>
-                </a:solidFill>
-                <a:latin typeface="Segoe UI"/>
-              </a:rPr>
-              <a:t>2 True positive</a:t>
-            </a:r>
-          </a:p>
-        </p:txBody>
-      </p:sp>
-      <p:sp>
-        <p:nvSpPr>
-          <p:cNvPr id="14" name="TextBox 13"/>
-          <p:cNvSpPr txBox="1"/>
-          <p:nvPr/>
-        </p:nvSpPr>
-        <p:spPr>
-          <a:xfrm>
-            <a:off x="1911096" y="2615184"/>
-            <a:ext cx="329184" cy="182880"/>
-          </a:xfrm>
-          <a:prstGeom prst="rect">
-            <a:avLst/>
-          </a:prstGeom>
-          <a:noFill/>
-        </p:spPr>
-        <p:txBody>
-          <a:bodyPr wrap="square" lIns="0" rIns="0" tIns="0" bIns="0">
-            <a:spAutoFit/>
-          </a:bodyPr>
-          <a:lstStyle/>
-          <a:p>
-            <a:pPr algn="l">
-              <a:lnSpc>
-                <a:spcPct val="125000"/>
-              </a:lnSpc>
-              <a:spcAft>
-                <a:spcPts val="600"/>
-              </a:spcAft>
-            </a:pPr>
-            <a:r>
-              <a:rPr sz="600" b="1">
-                <a:solidFill>
-                  <a:srgbClr val="A82D16"/>
-                </a:solidFill>
-                <a:latin typeface="Segoe UI"/>
-              </a:rPr>
-              <a:t>SUCC</a:t>
-            </a:r>
-          </a:p>
-        </p:txBody>
-      </p:sp>
-      <p:sp>
-        <p:nvSpPr>
-          <p:cNvPr id="15" name="TextBox 14"/>
-          <p:cNvSpPr txBox="1"/>
-          <p:nvPr/>
-        </p:nvSpPr>
-        <p:spPr>
-          <a:xfrm>
-            <a:off x="923544" y="2889504"/>
-            <a:ext cx="960120" cy="182880"/>
-          </a:xfrm>
-          <a:prstGeom prst="rect">
-            <a:avLst/>
-          </a:prstGeom>
-          <a:noFill/>
-        </p:spPr>
-        <p:txBody>
-          <a:bodyPr wrap="square" lIns="0" rIns="0" tIns="0" bIns="0">
-            <a:spAutoFit/>
-          </a:bodyPr>
-          <a:lstStyle/>
-          <a:p>
-            <a:pPr algn="l">
-              <a:lnSpc>
-                <a:spcPct val="125000"/>
-              </a:lnSpc>
-              <a:spcAft>
-                <a:spcPts val="600"/>
-              </a:spcAft>
-            </a:pPr>
-            <a:r>
-              <a:rPr sz="700" b="0">
-                <a:solidFill>
-                  <a:srgbClr val="8A8A94"/>
-                </a:solidFill>
-                <a:latin typeface="Segoe UI"/>
-              </a:rPr>
-              <a:t>3 Delayed evidence</a:t>
-            </a:r>
-          </a:p>
-        </p:txBody>
-      </p:sp>
-      <p:sp>
-        <p:nvSpPr>
-          <p:cNvPr id="16" name="TextBox 15"/>
-          <p:cNvSpPr txBox="1"/>
-          <p:nvPr/>
-        </p:nvSpPr>
-        <p:spPr>
-          <a:xfrm>
-            <a:off x="1911096" y="2889504"/>
-            <a:ext cx="329184" cy="182880"/>
-          </a:xfrm>
-          <a:prstGeom prst="rect">
-            <a:avLst/>
-          </a:prstGeom>
-          <a:noFill/>
-        </p:spPr>
-        <p:txBody>
-          <a:bodyPr wrap="square" lIns="0" rIns="0" tIns="0" bIns="0">
-            <a:spAutoFit/>
-          </a:bodyPr>
-          <a:lstStyle/>
-          <a:p>
-            <a:pPr algn="l">
-              <a:lnSpc>
-                <a:spcPct val="125000"/>
-              </a:lnSpc>
-              <a:spcAft>
-                <a:spcPts val="600"/>
-              </a:spcAft>
-            </a:pPr>
-            <a:r>
-              <a:rPr sz="600" b="1">
-                <a:solidFill>
-                  <a:srgbClr val="A82D16"/>
-                </a:solidFill>
-                <a:latin typeface="Segoe UI"/>
-              </a:rPr>
-              <a:t>SUCC</a:t>
-            </a:r>
-          </a:p>
-        </p:txBody>
-      </p:sp>
-      <p:sp>
-        <p:nvSpPr>
-          <p:cNvPr id="17" name="TextBox 16"/>
-          <p:cNvSpPr txBox="1"/>
-          <p:nvPr/>
-        </p:nvSpPr>
-        <p:spPr>
-          <a:xfrm>
-            <a:off x="923544" y="3163824"/>
-            <a:ext cx="960120" cy="182880"/>
-          </a:xfrm>
-          <a:prstGeom prst="rect">
-            <a:avLst/>
-          </a:prstGeom>
-          <a:noFill/>
-        </p:spPr>
-        <p:txBody>
-          <a:bodyPr wrap="square" lIns="0" rIns="0" tIns="0" bIns="0">
-            <a:spAutoFit/>
-          </a:bodyPr>
-          <a:lstStyle/>
-          <a:p>
-            <a:pPr algn="l">
-              <a:lnSpc>
-                <a:spcPct val="125000"/>
-              </a:lnSpc>
-              <a:spcAft>
-                <a:spcPts val="600"/>
-              </a:spcAft>
-            </a:pPr>
-            <a:r>
-              <a:rPr sz="700" b="0">
-                <a:solidFill>
-                  <a:srgbClr val="8A8A94"/>
-                </a:solidFill>
-                <a:latin typeface="Segoe UI"/>
-              </a:rPr>
-              <a:t>4 Human override</a:t>
-            </a:r>
-          </a:p>
-        </p:txBody>
-      </p:sp>
-      <p:sp>
-        <p:nvSpPr>
-          <p:cNvPr id="18" name="TextBox 17"/>
-          <p:cNvSpPr txBox="1"/>
-          <p:nvPr/>
-        </p:nvSpPr>
-        <p:spPr>
-          <a:xfrm>
-            <a:off x="1911096" y="3163824"/>
-            <a:ext cx="329184" cy="182880"/>
-          </a:xfrm>
-          <a:prstGeom prst="rect">
-            <a:avLst/>
-          </a:prstGeom>
-          <a:noFill/>
-        </p:spPr>
-        <p:txBody>
-          <a:bodyPr wrap="square" lIns="0" rIns="0" tIns="0" bIns="0">
-            <a:spAutoFit/>
-          </a:bodyPr>
-          <a:lstStyle/>
-          <a:p>
-            <a:pPr algn="l">
-              <a:lnSpc>
-                <a:spcPct val="125000"/>
-              </a:lnSpc>
-              <a:spcAft>
-                <a:spcPts val="600"/>
-              </a:spcAft>
-            </a:pPr>
-            <a:r>
-              <a:rPr sz="600" b="1">
-                <a:solidFill>
-                  <a:srgbClr val="A82D16"/>
-                </a:solidFill>
-                <a:latin typeface="Segoe UI"/>
-              </a:rPr>
-              <a:t>SUCC</a:t>
-            </a:r>
-          </a:p>
-        </p:txBody>
-      </p:sp>
-      <p:sp>
-        <p:nvSpPr>
-          <p:cNvPr id="19" name="TextBox 18"/>
-          <p:cNvSpPr txBox="1"/>
-          <p:nvPr/>
-        </p:nvSpPr>
-        <p:spPr>
-          <a:xfrm>
-            <a:off x="923544" y="3438144"/>
-            <a:ext cx="960120" cy="182880"/>
-          </a:xfrm>
-          <a:prstGeom prst="rect">
-            <a:avLst/>
-          </a:prstGeom>
-          <a:noFill/>
-        </p:spPr>
-        <p:txBody>
-          <a:bodyPr wrap="square" lIns="0" rIns="0" tIns="0" bIns="0">
-            <a:spAutoFit/>
-          </a:bodyPr>
-          <a:lstStyle/>
-          <a:p>
-            <a:pPr algn="l">
-              <a:lnSpc>
-                <a:spcPct val="125000"/>
-              </a:lnSpc>
-              <a:spcAft>
-                <a:spcPts val="600"/>
-              </a:spcAft>
-            </a:pPr>
-            <a:r>
-              <a:rPr sz="700" b="0">
-                <a:solidFill>
-                  <a:srgbClr val="8A8A94"/>
-                </a:solidFill>
-                <a:latin typeface="Segoe UI"/>
-              </a:rPr>
-              <a:t>5 Correlation</a:t>
-            </a:r>
-          </a:p>
-        </p:txBody>
-      </p:sp>
-      <p:sp>
-        <p:nvSpPr>
-          <p:cNvPr id="20" name="TextBox 19"/>
-          <p:cNvSpPr txBox="1"/>
-          <p:nvPr/>
-        </p:nvSpPr>
-        <p:spPr>
-          <a:xfrm>
-            <a:off x="1911096" y="3438144"/>
-            <a:ext cx="329184" cy="182880"/>
-          </a:xfrm>
-          <a:prstGeom prst="rect">
-            <a:avLst/>
-          </a:prstGeom>
-          <a:noFill/>
-        </p:spPr>
-        <p:txBody>
-          <a:bodyPr wrap="square" lIns="0" rIns="0" tIns="0" bIns="0">
-            <a:spAutoFit/>
-          </a:bodyPr>
-          <a:lstStyle/>
-          <a:p>
-            <a:pPr algn="l">
-              <a:lnSpc>
-                <a:spcPct val="125000"/>
-              </a:lnSpc>
-              <a:spcAft>
-                <a:spcPts val="600"/>
-              </a:spcAft>
-            </a:pPr>
-            <a:r>
-              <a:rPr sz="600" b="1">
-                <a:solidFill>
-                  <a:srgbClr val="A82D16"/>
-                </a:solidFill>
-                <a:latin typeface="Segoe UI"/>
-              </a:rPr>
-              <a:t>SUCC</a:t>
-            </a:r>
-          </a:p>
-        </p:txBody>
-      </p:sp>
-      <p:sp>
-        <p:nvSpPr>
-          <p:cNvPr id="21" name="TextBox 20"/>
-          <p:cNvSpPr txBox="1"/>
-          <p:nvPr/>
-        </p:nvSpPr>
-        <p:spPr>
-          <a:xfrm>
-            <a:off x="923544" y="3712464"/>
-            <a:ext cx="960120" cy="182880"/>
-          </a:xfrm>
-          <a:prstGeom prst="rect">
-            <a:avLst/>
-          </a:prstGeom>
-          <a:noFill/>
-        </p:spPr>
-        <p:txBody>
-          <a:bodyPr wrap="square" lIns="0" rIns="0" tIns="0" bIns="0">
-            <a:spAutoFit/>
-          </a:bodyPr>
-          <a:lstStyle/>
-          <a:p>
-            <a:pPr algn="l">
-              <a:lnSpc>
-                <a:spcPct val="125000"/>
-              </a:lnSpc>
-              <a:spcAft>
-                <a:spcPts val="600"/>
-              </a:spcAft>
-            </a:pPr>
-            <a:r>
-              <a:rPr sz="700" b="0">
-                <a:solidFill>
-                  <a:srgbClr val="8A8A94"/>
-                </a:solidFill>
-                <a:latin typeface="Segoe UI"/>
-              </a:rPr>
-              <a:t>6 Tool failure</a:t>
-            </a:r>
-          </a:p>
-        </p:txBody>
-      </p:sp>
-      <p:sp>
-        <p:nvSpPr>
-          <p:cNvPr id="22" name="TextBox 21"/>
-          <p:cNvSpPr txBox="1"/>
-          <p:nvPr/>
-        </p:nvSpPr>
-        <p:spPr>
-          <a:xfrm>
-            <a:off x="1911096" y="3712464"/>
-            <a:ext cx="329184" cy="182880"/>
-          </a:xfrm>
-          <a:prstGeom prst="rect">
-            <a:avLst/>
-          </a:prstGeom>
-          <a:noFill/>
-        </p:spPr>
-        <p:txBody>
-          <a:bodyPr wrap="square" lIns="0" rIns="0" tIns="0" bIns="0">
-            <a:spAutoFit/>
-          </a:bodyPr>
-          <a:lstStyle/>
-          <a:p>
-            <a:pPr algn="l">
-              <a:lnSpc>
-                <a:spcPct val="125000"/>
-              </a:lnSpc>
-              <a:spcAft>
-                <a:spcPts val="600"/>
-              </a:spcAft>
-            </a:pPr>
-            <a:r>
-              <a:rPr sz="600" b="1">
-                <a:solidFill>
-                  <a:srgbClr val="8A5E00"/>
-                </a:solidFill>
-                <a:latin typeface="Segoe UI"/>
-              </a:rPr>
-              <a:t>INC</a:t>
-            </a:r>
-          </a:p>
-        </p:txBody>
-      </p:sp>
-      <p:sp>
-        <p:nvSpPr>
-          <p:cNvPr id="23" name="TextBox 22"/>
-          <p:cNvSpPr txBox="1"/>
-          <p:nvPr/>
-        </p:nvSpPr>
-        <p:spPr>
-          <a:xfrm>
-            <a:off x="923544" y="3986784"/>
-            <a:ext cx="960120" cy="182880"/>
-          </a:xfrm>
-          <a:prstGeom prst="rect">
-            <a:avLst/>
-          </a:prstGeom>
-          <a:noFill/>
-        </p:spPr>
-        <p:txBody>
-          <a:bodyPr wrap="square" lIns="0" rIns="0" tIns="0" bIns="0">
-            <a:spAutoFit/>
-          </a:bodyPr>
-          <a:lstStyle/>
-          <a:p>
-            <a:pPr algn="l">
-              <a:lnSpc>
-                <a:spcPct val="125000"/>
-              </a:lnSpc>
-              <a:spcAft>
-                <a:spcPts val="600"/>
-              </a:spcAft>
-            </a:pPr>
-            <a:r>
-              <a:rPr sz="700" b="0">
-                <a:solidFill>
-                  <a:srgbClr val="8A8A94"/>
-                </a:solidFill>
-                <a:latin typeface="Segoe UI"/>
-              </a:rPr>
-              <a:t>7 Configuration</a:t>
-            </a:r>
-          </a:p>
-        </p:txBody>
-      </p:sp>
-      <p:sp>
-        <p:nvSpPr>
-          <p:cNvPr id="24" name="TextBox 23"/>
-          <p:cNvSpPr txBox="1"/>
-          <p:nvPr/>
-        </p:nvSpPr>
-        <p:spPr>
-          <a:xfrm>
-            <a:off x="1911096" y="3986784"/>
-            <a:ext cx="329184" cy="182880"/>
-          </a:xfrm>
-          <a:prstGeom prst="rect">
-            <a:avLst/>
-          </a:prstGeom>
-          <a:noFill/>
-        </p:spPr>
-        <p:txBody>
-          <a:bodyPr wrap="square" lIns="0" rIns="0" tIns="0" bIns="0">
-            <a:spAutoFit/>
-          </a:bodyPr>
-          <a:lstStyle/>
-          <a:p>
-            <a:pPr algn="l">
-              <a:lnSpc>
-                <a:spcPct val="125000"/>
-              </a:lnSpc>
-              <a:spcAft>
-                <a:spcPts val="600"/>
-              </a:spcAft>
-            </a:pPr>
-            <a:r>
-              <a:rPr sz="600" b="1">
-                <a:solidFill>
-                  <a:srgbClr val="8A5E00"/>
-                </a:solidFill>
-                <a:latin typeface="Segoe UI"/>
-              </a:rPr>
-              <a:t>INC</a:t>
-            </a:r>
-          </a:p>
-        </p:txBody>
-      </p:sp>
-      <p:sp>
-        <p:nvSpPr>
-          <p:cNvPr id="25" name="Rounded Rectangle 24"/>
-          <p:cNvSpPr/>
-          <p:nvPr/>
-        </p:nvSpPr>
-        <p:spPr>
-          <a:xfrm>
-            <a:off x="2478024" y="1901952"/>
-            <a:ext cx="1188720" cy="566928"/>
-          </a:xfrm>
-          <a:prstGeom prst="roundRect">
-            <a:avLst/>
-          </a:prstGeom>
-          <a:solidFill>
-            <a:srgbClr val="161616"/>
-          </a:solidFill>
-          <a:ln>
-            <a:solidFill>
-              <a:srgbClr val="2A2A2A"/>
-            </a:solidFill>
-          </a:ln>
-          <a:effectLst/>
-        </p:spPr>
-        <p:style>
-          <a:lnRef idx="1">
-            <a:schemeClr val="accent1"/>
-          </a:lnRef>
-          <a:fillRef idx="3">
-            <a:schemeClr val="accent1"/>
-          </a:fillRef>
-          <a:effectRef idx="2">
-            <a:schemeClr val="accent1"/>
-          </a:effectRef>
-          <a:fontRef idx="minor">
-            <a:schemeClr val="lt1"/>
-          </a:fontRef>
-        </p:style>
-        <p:txBody>
-          <a:bodyPr rtlCol="0" anchor="ctr"/>
-          <a:lstStyle/>
-          <a:p>
-            <a:pPr algn="ctr"/>
-          </a:p>
-        </p:txBody>
-      </p:sp>
-      <p:sp>
-        <p:nvSpPr>
-          <p:cNvPr id="26" name="TextBox 25"/>
-          <p:cNvSpPr txBox="1"/>
-          <p:nvPr/>
-        </p:nvSpPr>
-        <p:spPr>
-          <a:xfrm>
-            <a:off x="2560320" y="1965960"/>
-            <a:ext cx="1051560" cy="146304"/>
-          </a:xfrm>
-          <a:prstGeom prst="rect">
-            <a:avLst/>
-          </a:prstGeom>
-          <a:noFill/>
-        </p:spPr>
-        <p:txBody>
-          <a:bodyPr wrap="square" lIns="0" rIns="0" tIns="0" bIns="0">
-            <a:spAutoFit/>
-          </a:bodyPr>
-          <a:lstStyle/>
-          <a:p>
-            <a:pPr algn="l">
-              <a:lnSpc>
-                <a:spcPct val="125000"/>
-              </a:lnSpc>
-              <a:spcAft>
-                <a:spcPts val="600"/>
-              </a:spcAft>
-            </a:pPr>
-            <a:r>
-              <a:rPr sz="600" b="1">
-                <a:solidFill>
-                  <a:srgbClr val="8A8A94"/>
-                </a:solidFill>
-                <a:latin typeface="Segoe UI"/>
-              </a:rPr>
-              <a:t>OUTCOME</a:t>
-            </a:r>
-          </a:p>
-        </p:txBody>
-      </p:sp>
-      <p:sp>
-        <p:nvSpPr>
-          <p:cNvPr id="27" name="TextBox 26"/>
-          <p:cNvSpPr txBox="1"/>
-          <p:nvPr/>
-        </p:nvSpPr>
-        <p:spPr>
-          <a:xfrm>
-            <a:off x="2560320" y="2139696"/>
-            <a:ext cx="1051560" cy="201168"/>
-          </a:xfrm>
-          <a:prstGeom prst="rect">
-            <a:avLst/>
-          </a:prstGeom>
-          <a:noFill/>
-        </p:spPr>
-        <p:txBody>
-          <a:bodyPr wrap="square" lIns="0" rIns="0" tIns="0" bIns="0">
-            <a:spAutoFit/>
-          </a:bodyPr>
-          <a:lstStyle/>
-          <a:p>
-            <a:pPr algn="l">
-              <a:lnSpc>
-                <a:spcPct val="125000"/>
-              </a:lnSpc>
-              <a:spcAft>
-                <a:spcPts val="600"/>
-              </a:spcAft>
-            </a:pPr>
-            <a:r>
-              <a:rPr sz="900" b="1">
-                <a:solidFill>
-                  <a:srgbClr val="A82D16"/>
-                </a:solidFill>
-                <a:latin typeface="Segoe UI"/>
-              </a:rPr>
-              <a:t>SUCCEEDED</a:t>
-            </a:r>
-          </a:p>
-        </p:txBody>
-      </p:sp>
-      <p:sp>
-        <p:nvSpPr>
-          <p:cNvPr id="28" name="Rounded Rectangle 27"/>
-          <p:cNvSpPr/>
-          <p:nvPr/>
-        </p:nvSpPr>
-        <p:spPr>
-          <a:xfrm>
-            <a:off x="3721608" y="1901952"/>
-            <a:ext cx="1188720" cy="566928"/>
-          </a:xfrm>
-          <a:prstGeom prst="roundRect">
-            <a:avLst/>
-          </a:prstGeom>
-          <a:solidFill>
-            <a:srgbClr val="161616"/>
-          </a:solidFill>
-          <a:ln>
-            <a:solidFill>
-              <a:srgbClr val="2A2A2A"/>
-            </a:solidFill>
-          </a:ln>
-          <a:effectLst/>
-        </p:spPr>
-        <p:style>
-          <a:lnRef idx="1">
-            <a:schemeClr val="accent1"/>
-          </a:lnRef>
-          <a:fillRef idx="3">
-            <a:schemeClr val="accent1"/>
-          </a:fillRef>
-          <a:effectRef idx="2">
-            <a:schemeClr val="accent1"/>
-          </a:effectRef>
-          <a:fontRef idx="minor">
-            <a:schemeClr val="lt1"/>
-          </a:fontRef>
-        </p:style>
-        <p:txBody>
-          <a:bodyPr rtlCol="0" anchor="ctr"/>
-          <a:lstStyle/>
-          <a:p>
-            <a:pPr algn="ctr"/>
-          </a:p>
-        </p:txBody>
-      </p:sp>
-      <p:sp>
-        <p:nvSpPr>
-          <p:cNvPr id="29" name="TextBox 28"/>
-          <p:cNvSpPr txBox="1"/>
-          <p:nvPr/>
-        </p:nvSpPr>
-        <p:spPr>
-          <a:xfrm>
-            <a:off x="3803904" y="1965960"/>
-            <a:ext cx="1051560" cy="146304"/>
-          </a:xfrm>
-          <a:prstGeom prst="rect">
-            <a:avLst/>
-          </a:prstGeom>
-          <a:noFill/>
-        </p:spPr>
-        <p:txBody>
-          <a:bodyPr wrap="square" lIns="0" rIns="0" tIns="0" bIns="0">
-            <a:spAutoFit/>
-          </a:bodyPr>
-          <a:lstStyle/>
-          <a:p>
-            <a:pPr algn="l">
-              <a:lnSpc>
-                <a:spcPct val="125000"/>
-              </a:lnSpc>
-              <a:spcAft>
-                <a:spcPts val="600"/>
-              </a:spcAft>
-            </a:pPr>
-            <a:r>
-              <a:rPr sz="600" b="1">
-                <a:solidFill>
-                  <a:srgbClr val="8A8A94"/>
-                </a:solidFill>
-                <a:latin typeface="Segoe UI"/>
-              </a:rPr>
-              <a:t>CONFIDENCE</a:t>
-            </a:r>
-          </a:p>
-        </p:txBody>
-      </p:sp>
-      <p:sp>
-        <p:nvSpPr>
-          <p:cNvPr id="30" name="TextBox 29"/>
-          <p:cNvSpPr txBox="1"/>
-          <p:nvPr/>
-        </p:nvSpPr>
-        <p:spPr>
-          <a:xfrm>
-            <a:off x="3803904" y="2139696"/>
-            <a:ext cx="1051560" cy="201168"/>
-          </a:xfrm>
-          <a:prstGeom prst="rect">
-            <a:avLst/>
-          </a:prstGeom>
-          <a:noFill/>
-        </p:spPr>
-        <p:txBody>
-          <a:bodyPr wrap="square" lIns="0" rIns="0" tIns="0" bIns="0">
-            <a:spAutoFit/>
-          </a:bodyPr>
-          <a:lstStyle/>
-          <a:p>
-            <a:pPr algn="l">
-              <a:lnSpc>
-                <a:spcPct val="125000"/>
-              </a:lnSpc>
-              <a:spcAft>
-                <a:spcPts val="600"/>
-              </a:spcAft>
-            </a:pPr>
-            <a:r>
-              <a:rPr sz="900" b="1">
-                <a:solidFill>
-                  <a:srgbClr val="E4E4E7"/>
-                </a:solidFill>
-                <a:latin typeface="Segoe UI"/>
-              </a:rPr>
-              <a:t>0.95</a:t>
-            </a:r>
-          </a:p>
-        </p:txBody>
-      </p:sp>
-      <p:sp>
-        <p:nvSpPr>
-          <p:cNvPr id="31" name="Rounded Rectangle 30"/>
-          <p:cNvSpPr/>
-          <p:nvPr/>
-        </p:nvSpPr>
-        <p:spPr>
-          <a:xfrm>
-            <a:off x="4965192" y="1901952"/>
-            <a:ext cx="1188720" cy="566928"/>
-          </a:xfrm>
-          <a:prstGeom prst="roundRect">
-            <a:avLst/>
-          </a:prstGeom>
-          <a:solidFill>
-            <a:srgbClr val="161616"/>
-          </a:solidFill>
-          <a:ln>
-            <a:solidFill>
-              <a:srgbClr val="2A2A2A"/>
-            </a:solidFill>
-          </a:ln>
-          <a:effectLst/>
-        </p:spPr>
-        <p:style>
-          <a:lnRef idx="1">
-            <a:schemeClr val="accent1"/>
-          </a:lnRef>
-          <a:fillRef idx="3">
-            <a:schemeClr val="accent1"/>
-          </a:fillRef>
-          <a:effectRef idx="2">
-            <a:schemeClr val="accent1"/>
-          </a:effectRef>
-          <a:fontRef idx="minor">
-            <a:schemeClr val="lt1"/>
-          </a:fontRef>
-        </p:style>
-        <p:txBody>
-          <a:bodyPr rtlCol="0" anchor="ctr"/>
-          <a:lstStyle/>
-          <a:p>
-            <a:pPr algn="ctr"/>
-          </a:p>
-        </p:txBody>
-      </p:sp>
-      <p:sp>
-        <p:nvSpPr>
-          <p:cNvPr id="32" name="TextBox 31"/>
-          <p:cNvSpPr txBox="1"/>
-          <p:nvPr/>
-        </p:nvSpPr>
-        <p:spPr>
-          <a:xfrm>
-            <a:off x="5047488" y="1965960"/>
-            <a:ext cx="1051560" cy="146304"/>
-          </a:xfrm>
-          <a:prstGeom prst="rect">
-            <a:avLst/>
-          </a:prstGeom>
-          <a:noFill/>
-        </p:spPr>
-        <p:txBody>
-          <a:bodyPr wrap="square" lIns="0" rIns="0" tIns="0" bIns="0">
-            <a:spAutoFit/>
-          </a:bodyPr>
-          <a:lstStyle/>
-          <a:p>
-            <a:pPr algn="l">
-              <a:lnSpc>
-                <a:spcPct val="125000"/>
-              </a:lnSpc>
-              <a:spcAft>
-                <a:spcPts val="600"/>
-              </a:spcAft>
-            </a:pPr>
-            <a:r>
-              <a:rPr sz="600" b="1">
-                <a:solidFill>
-                  <a:srgbClr val="8A8A94"/>
-                </a:solidFill>
-                <a:latin typeface="Segoe UI"/>
-              </a:rPr>
-              <a:t>EVIDENCE</a:t>
-            </a:r>
-          </a:p>
-        </p:txBody>
-      </p:sp>
-      <p:sp>
-        <p:nvSpPr>
-          <p:cNvPr id="33" name="TextBox 32"/>
-          <p:cNvSpPr txBox="1"/>
-          <p:nvPr/>
-        </p:nvSpPr>
-        <p:spPr>
-          <a:xfrm>
-            <a:off x="5047488" y="2139696"/>
-            <a:ext cx="1051560" cy="201168"/>
-          </a:xfrm>
-          <a:prstGeom prst="rect">
-            <a:avLst/>
-          </a:prstGeom>
-          <a:noFill/>
-        </p:spPr>
-        <p:txBody>
-          <a:bodyPr wrap="square" lIns="0" rIns="0" tIns="0" bIns="0">
-            <a:spAutoFit/>
-          </a:bodyPr>
-          <a:lstStyle/>
-          <a:p>
-            <a:pPr algn="l">
-              <a:lnSpc>
-                <a:spcPct val="125000"/>
-              </a:lnSpc>
-              <a:spcAft>
-                <a:spcPts val="600"/>
-              </a:spcAft>
-            </a:pPr>
-            <a:r>
-              <a:rPr sz="900" b="1">
-                <a:solidFill>
-                  <a:srgbClr val="E4E4E7"/>
-                </a:solidFill>
-                <a:latin typeface="Segoe UI"/>
-              </a:rPr>
-              <a:t>9</a:t>
-            </a:r>
-          </a:p>
-        </p:txBody>
-      </p:sp>
-      <p:sp>
-        <p:nvSpPr>
-          <p:cNvPr id="34" name="Rounded Rectangle 33"/>
-          <p:cNvSpPr/>
-          <p:nvPr/>
-        </p:nvSpPr>
-        <p:spPr>
-          <a:xfrm>
-            <a:off x="6208776" y="1901952"/>
-            <a:ext cx="1188720" cy="566928"/>
-          </a:xfrm>
-          <a:prstGeom prst="roundRect">
-            <a:avLst/>
-          </a:prstGeom>
-          <a:solidFill>
-            <a:srgbClr val="161616"/>
-          </a:solidFill>
-          <a:ln>
-            <a:solidFill>
-              <a:srgbClr val="2A2A2A"/>
-            </a:solidFill>
-          </a:ln>
-          <a:effectLst/>
-        </p:spPr>
-        <p:style>
-          <a:lnRef idx="1">
-            <a:schemeClr val="accent1"/>
-          </a:lnRef>
-          <a:fillRef idx="3">
-            <a:schemeClr val="accent1"/>
-          </a:fillRef>
-          <a:effectRef idx="2">
-            <a:schemeClr val="accent1"/>
-          </a:effectRef>
-          <a:fontRef idx="minor">
-            <a:schemeClr val="lt1"/>
-          </a:fontRef>
-        </p:style>
-        <p:txBody>
-          <a:bodyPr rtlCol="0" anchor="ctr"/>
-          <a:lstStyle/>
-          <a:p>
-            <a:pPr algn="ctr"/>
-          </a:p>
-        </p:txBody>
-      </p:sp>
-      <p:sp>
-        <p:nvSpPr>
-          <p:cNvPr id="35" name="TextBox 34"/>
-          <p:cNvSpPr txBox="1"/>
-          <p:nvPr/>
-        </p:nvSpPr>
-        <p:spPr>
-          <a:xfrm>
-            <a:off x="6291072" y="1965960"/>
-            <a:ext cx="1051560" cy="146304"/>
-          </a:xfrm>
-          <a:prstGeom prst="rect">
-            <a:avLst/>
-          </a:prstGeom>
-          <a:noFill/>
-        </p:spPr>
-        <p:txBody>
-          <a:bodyPr wrap="square" lIns="0" rIns="0" tIns="0" bIns="0">
-            <a:spAutoFit/>
-          </a:bodyPr>
-          <a:lstStyle/>
-          <a:p>
-            <a:pPr algn="l">
-              <a:lnSpc>
-                <a:spcPct val="125000"/>
-              </a:lnSpc>
-              <a:spcAft>
-                <a:spcPts val="600"/>
-              </a:spcAft>
-            </a:pPr>
-            <a:r>
-              <a:rPr sz="600" b="1">
-                <a:solidFill>
-                  <a:srgbClr val="8A8A94"/>
-                </a:solidFill>
-                <a:latin typeface="Segoe UI"/>
-              </a:rPr>
-              <a:t>REFUSALS</a:t>
-            </a:r>
-          </a:p>
-        </p:txBody>
-      </p:sp>
-      <p:sp>
-        <p:nvSpPr>
-          <p:cNvPr id="36" name="TextBox 35"/>
-          <p:cNvSpPr txBox="1"/>
-          <p:nvPr/>
-        </p:nvSpPr>
-        <p:spPr>
-          <a:xfrm>
-            <a:off x="6291072" y="2139696"/>
-            <a:ext cx="1051560" cy="201168"/>
-          </a:xfrm>
-          <a:prstGeom prst="rect">
-            <a:avLst/>
-          </a:prstGeom>
-          <a:noFill/>
-        </p:spPr>
-        <p:txBody>
-          <a:bodyPr wrap="square" lIns="0" rIns="0" tIns="0" bIns="0">
-            <a:spAutoFit/>
-          </a:bodyPr>
-          <a:lstStyle/>
-          <a:p>
-            <a:pPr algn="l">
-              <a:lnSpc>
-                <a:spcPct val="125000"/>
-              </a:lnSpc>
-              <a:spcAft>
-                <a:spcPts val="600"/>
-              </a:spcAft>
-            </a:pPr>
-            <a:r>
-              <a:rPr sz="900" b="1">
-                <a:solidFill>
-                  <a:srgbClr val="E4E4E7"/>
-                </a:solidFill>
-                <a:latin typeface="Segoe UI"/>
-              </a:rPr>
-              <a:t>1</a:t>
-            </a:r>
-          </a:p>
-        </p:txBody>
-      </p:sp>
-      <p:sp>
-        <p:nvSpPr>
-          <p:cNvPr id="37" name="Rounded Rectangle 36"/>
-          <p:cNvSpPr/>
-          <p:nvPr/>
-        </p:nvSpPr>
-        <p:spPr>
-          <a:xfrm>
-            <a:off x="2478024" y="2606040"/>
-            <a:ext cx="4983480" cy="457200"/>
-          </a:xfrm>
-          <a:prstGeom prst="roundRect">
-            <a:avLst/>
-          </a:prstGeom>
-          <a:solidFill>
-            <a:srgbClr val="161616"/>
-          </a:solidFill>
-          <a:ln>
-            <a:solidFill>
-              <a:srgbClr val="2A2A2A"/>
-            </a:solidFill>
-          </a:ln>
-          <a:effectLst/>
-        </p:spPr>
-        <p:style>
-          <a:lnRef idx="1">
-            <a:schemeClr val="accent1"/>
-          </a:lnRef>
-          <a:fillRef idx="3">
-            <a:schemeClr val="accent1"/>
-          </a:fillRef>
-          <a:effectRef idx="2">
-            <a:schemeClr val="accent1"/>
-          </a:effectRef>
-          <a:fontRef idx="minor">
-            <a:schemeClr val="lt1"/>
-          </a:fontRef>
-        </p:style>
-        <p:txBody>
-          <a:bodyPr rtlCol="0" anchor="ctr"/>
-          <a:lstStyle/>
-          <a:p>
-            <a:pPr algn="ctr"/>
-          </a:p>
-        </p:txBody>
-      </p:sp>
-      <p:sp>
-        <p:nvSpPr>
-          <p:cNvPr id="38" name="TextBox 37"/>
-          <p:cNvSpPr txBox="1"/>
-          <p:nvPr/>
-        </p:nvSpPr>
-        <p:spPr>
-          <a:xfrm>
-            <a:off x="2587752" y="2660904"/>
-            <a:ext cx="4754880" cy="146304"/>
-          </a:xfrm>
-          <a:prstGeom prst="rect">
-            <a:avLst/>
-          </a:prstGeom>
-          <a:noFill/>
-        </p:spPr>
-        <p:txBody>
-          <a:bodyPr wrap="square" lIns="0" rIns="0" tIns="0" bIns="0">
-            <a:spAutoFit/>
-          </a:bodyPr>
-          <a:lstStyle/>
-          <a:p>
-            <a:pPr algn="l">
-              <a:lnSpc>
-                <a:spcPct val="125000"/>
-              </a:lnSpc>
-              <a:spcAft>
-                <a:spcPts val="600"/>
-              </a:spcAft>
-            </a:pPr>
-            <a:r>
-              <a:rPr sz="600" b="1">
-                <a:solidFill>
-                  <a:srgbClr val="39FF14"/>
-                </a:solidFill>
-                <a:latin typeface="Segoe UI"/>
-              </a:rPr>
-              <a:t>TOOL CALL</a:t>
-            </a:r>
-          </a:p>
-        </p:txBody>
-      </p:sp>
-      <p:sp>
-        <p:nvSpPr>
-          <p:cNvPr id="39" name="TextBox 38"/>
-          <p:cNvSpPr txBox="1"/>
-          <p:nvPr/>
-        </p:nvSpPr>
-        <p:spPr>
-          <a:xfrm>
-            <a:off x="2587752" y="2816352"/>
-            <a:ext cx="4754880" cy="219456"/>
-          </a:xfrm>
-          <a:prstGeom prst="rect">
-            <a:avLst/>
-          </a:prstGeom>
-          <a:noFill/>
-        </p:spPr>
-        <p:txBody>
-          <a:bodyPr wrap="square" lIns="0" rIns="0" tIns="0" bIns="0">
-            <a:spAutoFit/>
-          </a:bodyPr>
-          <a:lstStyle/>
-          <a:p>
-            <a:pPr algn="l">
-              <a:lnSpc>
-                <a:spcPct val="125000"/>
-              </a:lnSpc>
-              <a:spcAft>
-                <a:spcPts val="600"/>
-              </a:spcAft>
-            </a:pPr>
-            <a:r>
-              <a:rPr sz="700" b="0">
-                <a:solidFill>
-                  <a:srgbClr val="E4E4E7"/>
-                </a:solidFill>
-                <a:latin typeface="Consolas"/>
-              </a:rPr>
-              <a:t>get_asset_info(asset_id='SRV-DB-02')</a:t>
-            </a:r>
-          </a:p>
-        </p:txBody>
-      </p:sp>
-      <p:sp>
-        <p:nvSpPr>
-          <p:cNvPr id="40" name="Rounded Rectangle 39"/>
-          <p:cNvSpPr/>
-          <p:nvPr/>
-        </p:nvSpPr>
-        <p:spPr>
-          <a:xfrm>
-            <a:off x="2478024" y="3118104"/>
-            <a:ext cx="4983480" cy="457200"/>
-          </a:xfrm>
-          <a:prstGeom prst="roundRect">
-            <a:avLst/>
-          </a:prstGeom>
-          <a:solidFill>
-            <a:srgbClr val="161616"/>
-          </a:solidFill>
-          <a:ln>
-            <a:solidFill>
-              <a:srgbClr val="2A2A2A"/>
-            </a:solidFill>
-          </a:ln>
-          <a:effectLst/>
-        </p:spPr>
-        <p:style>
-          <a:lnRef idx="1">
-            <a:schemeClr val="accent1"/>
-          </a:lnRef>
-          <a:fillRef idx="3">
-            <a:schemeClr val="accent1"/>
-          </a:fillRef>
-          <a:effectRef idx="2">
-            <a:schemeClr val="accent1"/>
-          </a:effectRef>
-          <a:fontRef idx="minor">
-            <a:schemeClr val="lt1"/>
-          </a:fontRef>
-        </p:style>
-        <p:txBody>
-          <a:bodyPr rtlCol="0" anchor="ctr"/>
-          <a:lstStyle/>
-          <a:p>
-            <a:pPr algn="ctr"/>
-          </a:p>
-        </p:txBody>
-      </p:sp>
-      <p:sp>
-        <p:nvSpPr>
-          <p:cNvPr id="41" name="TextBox 40"/>
-          <p:cNvSpPr txBox="1"/>
-          <p:nvPr/>
-        </p:nvSpPr>
-        <p:spPr>
-          <a:xfrm>
-            <a:off x="2587752" y="3172968"/>
-            <a:ext cx="4754880" cy="146304"/>
-          </a:xfrm>
-          <a:prstGeom prst="rect">
-            <a:avLst/>
-          </a:prstGeom>
-          <a:noFill/>
-        </p:spPr>
-        <p:txBody>
-          <a:bodyPr wrap="square" lIns="0" rIns="0" tIns="0" bIns="0">
-            <a:spAutoFit/>
-          </a:bodyPr>
-          <a:lstStyle/>
-          <a:p>
-            <a:pPr algn="l">
-              <a:lnSpc>
-                <a:spcPct val="125000"/>
-              </a:lnSpc>
-              <a:spcAft>
-                <a:spcPts val="600"/>
-              </a:spcAft>
-            </a:pPr>
-            <a:r>
-              <a:rPr sz="600" b="1">
-                <a:solidFill>
-                  <a:srgbClr val="8A8A94"/>
-                </a:solidFill>
-                <a:latin typeface="Segoe UI"/>
-              </a:rPr>
-              <a:t>RESULT  OK</a:t>
-            </a:r>
-          </a:p>
-        </p:txBody>
-      </p:sp>
-      <p:sp>
-        <p:nvSpPr>
-          <p:cNvPr id="42" name="TextBox 41"/>
-          <p:cNvSpPr txBox="1"/>
-          <p:nvPr/>
-        </p:nvSpPr>
-        <p:spPr>
-          <a:xfrm>
-            <a:off x="2587752" y="3328416"/>
-            <a:ext cx="4754880" cy="219456"/>
-          </a:xfrm>
-          <a:prstGeom prst="rect">
-            <a:avLst/>
-          </a:prstGeom>
-          <a:noFill/>
-        </p:spPr>
-        <p:txBody>
-          <a:bodyPr wrap="square" lIns="0" rIns="0" tIns="0" bIns="0">
-            <a:spAutoFit/>
-          </a:bodyPr>
-          <a:lstStyle/>
-          <a:p>
-            <a:pPr algn="l">
-              <a:lnSpc>
-                <a:spcPct val="125000"/>
-              </a:lnSpc>
-              <a:spcAft>
-                <a:spcPts val="600"/>
-              </a:spcAft>
-            </a:pPr>
-            <a:r>
-              <a:rPr sz="700" b="0">
-                <a:solidFill>
-                  <a:srgbClr val="E4E4E7"/>
-                </a:solidFill>
-                <a:latin typeface="Segoe UI"/>
-              </a:rPr>
-              <a:t>mysql 5.7.21 running</a:t>
-            </a:r>
-          </a:p>
-        </p:txBody>
-      </p:sp>
-      <p:sp>
-        <p:nvSpPr>
-          <p:cNvPr id="43" name="Rounded Rectangle 42"/>
-          <p:cNvSpPr/>
-          <p:nvPr/>
-        </p:nvSpPr>
-        <p:spPr>
-          <a:xfrm>
-            <a:off x="2478024" y="3630168"/>
-            <a:ext cx="4983480" cy="457200"/>
-          </a:xfrm>
-          <a:prstGeom prst="roundRect">
-            <a:avLst/>
-          </a:prstGeom>
-          <a:solidFill>
-            <a:srgbClr val="161616"/>
-          </a:solidFill>
-          <a:ln>
-            <a:solidFill>
-              <a:srgbClr val="2A2A2A"/>
-            </a:solidFill>
-          </a:ln>
-          <a:effectLst/>
-        </p:spPr>
-        <p:style>
-          <a:lnRef idx="1">
-            <a:schemeClr val="accent1"/>
-          </a:lnRef>
-          <a:fillRef idx="3">
-            <a:schemeClr val="accent1"/>
-          </a:fillRef>
-          <a:effectRef idx="2">
-            <a:schemeClr val="accent1"/>
-          </a:effectRef>
-          <a:fontRef idx="minor">
-            <a:schemeClr val="lt1"/>
-          </a:fontRef>
-        </p:style>
-        <p:txBody>
-          <a:bodyPr rtlCol="0" anchor="ctr"/>
-          <a:lstStyle/>
-          <a:p>
-            <a:pPr algn="ctr"/>
-          </a:p>
-        </p:txBody>
-      </p:sp>
-      <p:sp>
-        <p:nvSpPr>
-          <p:cNvPr id="44" name="TextBox 43"/>
-          <p:cNvSpPr txBox="1"/>
-          <p:nvPr/>
-        </p:nvSpPr>
-        <p:spPr>
-          <a:xfrm>
-            <a:off x="2587752" y="3685032"/>
-            <a:ext cx="4754880" cy="146304"/>
-          </a:xfrm>
-          <a:prstGeom prst="rect">
-            <a:avLst/>
-          </a:prstGeom>
-          <a:noFill/>
-        </p:spPr>
-        <p:txBody>
-          <a:bodyPr wrap="square" lIns="0" rIns="0" tIns="0" bIns="0">
-            <a:spAutoFit/>
-          </a:bodyPr>
-          <a:lstStyle/>
-          <a:p>
-            <a:pPr algn="l">
-              <a:lnSpc>
-                <a:spcPct val="125000"/>
-              </a:lnSpc>
-              <a:spcAft>
-                <a:spcPts val="600"/>
-              </a:spcAft>
-            </a:pPr>
-            <a:r>
-              <a:rPr sz="600" b="1">
-                <a:solidFill>
-                  <a:srgbClr val="39FF14"/>
-                </a:solidFill>
-                <a:latin typeface="Segoe UI"/>
-              </a:rPr>
-              <a:t>TOOL CALL</a:t>
-            </a:r>
-          </a:p>
-        </p:txBody>
-      </p:sp>
-      <p:sp>
-        <p:nvSpPr>
-          <p:cNvPr id="45" name="TextBox 44"/>
-          <p:cNvSpPr txBox="1"/>
-          <p:nvPr/>
-        </p:nvSpPr>
-        <p:spPr>
-          <a:xfrm>
-            <a:off x="2587752" y="3840480"/>
-            <a:ext cx="4754880" cy="219456"/>
-          </a:xfrm>
-          <a:prstGeom prst="rect">
-            <a:avLst/>
-          </a:prstGeom>
-          <a:noFill/>
-        </p:spPr>
-        <p:txBody>
-          <a:bodyPr wrap="square" lIns="0" rIns="0" tIns="0" bIns="0">
-            <a:spAutoFit/>
-          </a:bodyPr>
-          <a:lstStyle/>
-          <a:p>
-            <a:pPr algn="l">
-              <a:lnSpc>
-                <a:spcPct val="125000"/>
-              </a:lnSpc>
-              <a:spcAft>
-                <a:spcPts val="600"/>
-              </a:spcAft>
-            </a:pPr>
-            <a:r>
-              <a:rPr sz="700" b="0">
-                <a:solidFill>
-                  <a:srgbClr val="E4E4E7"/>
-                </a:solidFill>
-                <a:latin typeface="Consolas"/>
-              </a:rPr>
-              <a:t>get_vulnerabilities(service_name='mysql')</a:t>
-            </a:r>
-          </a:p>
-        </p:txBody>
-      </p:sp>
-      <p:sp>
-        <p:nvSpPr>
-          <p:cNvPr id="46" name="Rounded Rectangle 45"/>
-          <p:cNvSpPr/>
-          <p:nvPr/>
-        </p:nvSpPr>
-        <p:spPr>
-          <a:xfrm>
-            <a:off x="2478024" y="4142232"/>
-            <a:ext cx="4983480" cy="457200"/>
-          </a:xfrm>
-          <a:prstGeom prst="roundRect">
-            <a:avLst/>
-          </a:prstGeom>
-          <a:solidFill>
-            <a:srgbClr val="24100F"/>
-          </a:solidFill>
-          <a:ln>
-            <a:solidFill>
-              <a:srgbClr val="2A2A2A"/>
-            </a:solidFill>
-          </a:ln>
-          <a:effectLst/>
-        </p:spPr>
-        <p:style>
-          <a:lnRef idx="1">
-            <a:schemeClr val="accent1"/>
-          </a:lnRef>
-          <a:fillRef idx="3">
-            <a:schemeClr val="accent1"/>
-          </a:fillRef>
-          <a:effectRef idx="2">
-            <a:schemeClr val="accent1"/>
-          </a:effectRef>
-          <a:fontRef idx="minor">
-            <a:schemeClr val="lt1"/>
-          </a:fontRef>
-        </p:style>
-        <p:txBody>
-          <a:bodyPr rtlCol="0" anchor="ctr"/>
-          <a:lstStyle/>
-          <a:p>
-            <a:pPr algn="ctr"/>
-          </a:p>
-        </p:txBody>
-      </p:sp>
-      <p:sp>
-        <p:nvSpPr>
-          <p:cNvPr id="47" name="TextBox 46"/>
-          <p:cNvSpPr txBox="1"/>
-          <p:nvPr/>
-        </p:nvSpPr>
-        <p:spPr>
-          <a:xfrm>
-            <a:off x="2587752" y="4197096"/>
-            <a:ext cx="4754880" cy="146304"/>
-          </a:xfrm>
-          <a:prstGeom prst="rect">
-            <a:avLst/>
-          </a:prstGeom>
-          <a:noFill/>
-        </p:spPr>
-        <p:txBody>
-          <a:bodyPr wrap="square" lIns="0" rIns="0" tIns="0" bIns="0">
-            <a:spAutoFit/>
-          </a:bodyPr>
-          <a:lstStyle/>
-          <a:p>
-            <a:pPr algn="l">
-              <a:lnSpc>
-                <a:spcPct val="125000"/>
-              </a:lnSpc>
-              <a:spcAft>
-                <a:spcPts val="600"/>
-              </a:spcAft>
-            </a:pPr>
-            <a:r>
-              <a:rPr sz="600" b="1">
-                <a:solidFill>
-                  <a:srgbClr val="A82D16"/>
-                </a:solidFill>
-                <a:latin typeface="Segoe UI"/>
-              </a:rPr>
-              <a:t>RESULT  REJECTED</a:t>
-            </a:r>
-          </a:p>
-        </p:txBody>
-      </p:sp>
-      <p:sp>
-        <p:nvSpPr>
-          <p:cNvPr id="48" name="TextBox 47"/>
-          <p:cNvSpPr txBox="1"/>
-          <p:nvPr/>
-        </p:nvSpPr>
-        <p:spPr>
-          <a:xfrm>
-            <a:off x="2587752" y="4352544"/>
-            <a:ext cx="4754880" cy="219456"/>
-          </a:xfrm>
-          <a:prstGeom prst="rect">
-            <a:avLst/>
-          </a:prstGeom>
-          <a:noFill/>
-        </p:spPr>
-        <p:txBody>
-          <a:bodyPr wrap="square" lIns="0" rIns="0" tIns="0" bIns="0">
-            <a:spAutoFit/>
-          </a:bodyPr>
-          <a:lstStyle/>
-          <a:p>
-            <a:pPr algn="l">
-              <a:lnSpc>
-                <a:spcPct val="125000"/>
-              </a:lnSpc>
-              <a:spcAft>
-                <a:spcPts val="600"/>
-              </a:spcAft>
-            </a:pPr>
-            <a:r>
-              <a:rPr sz="700" b="0">
-                <a:solidFill>
-                  <a:srgbClr val="E4E4E7"/>
-                </a:solidFill>
-                <a:latin typeface="Segoe UI"/>
-              </a:rPr>
-              <a:t>factor 'version_patched' claims the host is outside ALL ranges, but openssh was never looked up</a:t>
-            </a:r>
-          </a:p>
-        </p:txBody>
-      </p:sp>
-      <p:sp>
-        <p:nvSpPr>
-          <p:cNvPr id="49" name="Rounded Rectangle 48"/>
-          <p:cNvSpPr/>
-          <p:nvPr/>
-        </p:nvSpPr>
-        <p:spPr>
-          <a:xfrm>
-            <a:off x="2478024" y="4654296"/>
-            <a:ext cx="4983480" cy="457200"/>
-          </a:xfrm>
-          <a:prstGeom prst="roundRect">
-            <a:avLst/>
-          </a:prstGeom>
-          <a:solidFill>
-            <a:srgbClr val="161616"/>
-          </a:solidFill>
-          <a:ln>
-            <a:solidFill>
-              <a:srgbClr val="2A2A2A"/>
-            </a:solidFill>
-          </a:ln>
-          <a:effectLst/>
-        </p:spPr>
-        <p:style>
-          <a:lnRef idx="1">
-            <a:schemeClr val="accent1"/>
-          </a:lnRef>
-          <a:fillRef idx="3">
-            <a:schemeClr val="accent1"/>
-          </a:fillRef>
-          <a:effectRef idx="2">
-            <a:schemeClr val="accent1"/>
-          </a:effectRef>
-          <a:fontRef idx="minor">
-            <a:schemeClr val="lt1"/>
-          </a:fontRef>
-        </p:style>
-        <p:txBody>
-          <a:bodyPr rtlCol="0" anchor="ctr"/>
-          <a:lstStyle/>
-          <a:p>
-            <a:pPr algn="ctr"/>
-          </a:p>
-        </p:txBody>
-      </p:sp>
-      <p:sp>
-        <p:nvSpPr>
-          <p:cNvPr id="50" name="TextBox 49"/>
-          <p:cNvSpPr txBox="1"/>
-          <p:nvPr/>
-        </p:nvSpPr>
-        <p:spPr>
-          <a:xfrm>
-            <a:off x="2587752" y="4709160"/>
-            <a:ext cx="4754880" cy="146304"/>
-          </a:xfrm>
-          <a:prstGeom prst="rect">
-            <a:avLst/>
-          </a:prstGeom>
-          <a:noFill/>
-        </p:spPr>
-        <p:txBody>
-          <a:bodyPr wrap="square" lIns="0" rIns="0" tIns="0" bIns="0">
-            <a:spAutoFit/>
-          </a:bodyPr>
-          <a:lstStyle/>
-          <a:p>
-            <a:pPr algn="l">
-              <a:lnSpc>
-                <a:spcPct val="125000"/>
-              </a:lnSpc>
-              <a:spcAft>
-                <a:spcPts val="600"/>
-              </a:spcAft>
-            </a:pPr>
-            <a:r>
-              <a:rPr sz="600" b="1">
-                <a:solidFill>
-                  <a:srgbClr val="E4E4E7"/>
-                </a:solidFill>
-                <a:latin typeface="Segoe UI"/>
-              </a:rPr>
-              <a:t>REASONING</a:t>
-            </a:r>
-          </a:p>
-        </p:txBody>
-      </p:sp>
-      <p:sp>
-        <p:nvSpPr>
-          <p:cNvPr id="51" name="TextBox 50"/>
-          <p:cNvSpPr txBox="1"/>
-          <p:nvPr/>
-        </p:nvSpPr>
-        <p:spPr>
-          <a:xfrm>
-            <a:off x="2587752" y="4864608"/>
-            <a:ext cx="4754880" cy="219456"/>
-          </a:xfrm>
-          <a:prstGeom prst="rect">
-            <a:avLst/>
-          </a:prstGeom>
-          <a:noFill/>
-        </p:spPr>
-        <p:txBody>
-          <a:bodyPr wrap="square" lIns="0" rIns="0" tIns="0" bIns="0">
-            <a:spAutoFit/>
-          </a:bodyPr>
-          <a:lstStyle/>
-          <a:p>
-            <a:pPr algn="l">
-              <a:lnSpc>
-                <a:spcPct val="125000"/>
-              </a:lnSpc>
-              <a:spcAft>
-                <a:spcPts val="600"/>
-              </a:spcAft>
-            </a:pPr>
-            <a:r>
-              <a:rPr sz="700" b="0">
-                <a:solidFill>
-                  <a:srgbClr val="E4E4E7"/>
-                </a:solidFill>
-                <a:latin typeface="Segoe UI"/>
-              </a:rPr>
-              <a:t>I need to fix two issues. Let me check openssh CVEs.</a:t>
-            </a:r>
-          </a:p>
-        </p:txBody>
-      </p:sp>
-      <p:sp>
-        <p:nvSpPr>
-          <p:cNvPr id="52" name="Rounded Rectangle 51"/>
-          <p:cNvSpPr/>
-          <p:nvPr/>
-        </p:nvSpPr>
-        <p:spPr>
-          <a:xfrm>
-            <a:off x="2478024" y="5166360"/>
-            <a:ext cx="4983480" cy="457200"/>
-          </a:xfrm>
-          <a:prstGeom prst="roundRect">
-            <a:avLst/>
-          </a:prstGeom>
-          <a:solidFill>
-            <a:srgbClr val="161616"/>
-          </a:solidFill>
-          <a:ln>
-            <a:solidFill>
-              <a:srgbClr val="2A2A2A"/>
-            </a:solidFill>
-          </a:ln>
-          <a:effectLst/>
-        </p:spPr>
-        <p:style>
-          <a:lnRef idx="1">
-            <a:schemeClr val="accent1"/>
-          </a:lnRef>
-          <a:fillRef idx="3">
-            <a:schemeClr val="accent1"/>
-          </a:fillRef>
-          <a:effectRef idx="2">
-            <a:schemeClr val="accent1"/>
-          </a:effectRef>
-          <a:fontRef idx="minor">
-            <a:schemeClr val="lt1"/>
-          </a:fontRef>
-        </p:style>
-        <p:txBody>
-          <a:bodyPr rtlCol="0" anchor="ctr"/>
-          <a:lstStyle/>
-          <a:p>
-            <a:pPr algn="ctr"/>
-          </a:p>
-        </p:txBody>
-      </p:sp>
-      <p:sp>
-        <p:nvSpPr>
-          <p:cNvPr id="53" name="TextBox 52"/>
-          <p:cNvSpPr txBox="1"/>
-          <p:nvPr/>
-        </p:nvSpPr>
-        <p:spPr>
-          <a:xfrm>
-            <a:off x="2587752" y="5221224"/>
-            <a:ext cx="4754880" cy="146304"/>
-          </a:xfrm>
-          <a:prstGeom prst="rect">
-            <a:avLst/>
-          </a:prstGeom>
-          <a:noFill/>
-        </p:spPr>
-        <p:txBody>
-          <a:bodyPr wrap="square" lIns="0" rIns="0" tIns="0" bIns="0">
-            <a:spAutoFit/>
-          </a:bodyPr>
-          <a:lstStyle/>
-          <a:p>
-            <a:pPr algn="l">
-              <a:lnSpc>
-                <a:spcPct val="125000"/>
-              </a:lnSpc>
-              <a:spcAft>
-                <a:spcPts val="600"/>
-              </a:spcAft>
-            </a:pPr>
-            <a:r>
-              <a:rPr sz="600" b="1">
-                <a:solidFill>
-                  <a:srgbClr val="8A5E00"/>
-                </a:solidFill>
-                <a:latin typeface="Segoe UI"/>
-              </a:rPr>
-              <a:t>SCORING</a:t>
-            </a:r>
-          </a:p>
-        </p:txBody>
-      </p:sp>
-      <p:sp>
-        <p:nvSpPr>
-          <p:cNvPr id="54" name="TextBox 53"/>
-          <p:cNvSpPr txBox="1"/>
-          <p:nvPr/>
-        </p:nvSpPr>
-        <p:spPr>
-          <a:xfrm>
-            <a:off x="2587752" y="5376672"/>
-            <a:ext cx="4754880" cy="219456"/>
-          </a:xfrm>
-          <a:prstGeom prst="rect">
-            <a:avLst/>
-          </a:prstGeom>
-          <a:noFill/>
-        </p:spPr>
-        <p:txBody>
-          <a:bodyPr wrap="square" lIns="0" rIns="0" tIns="0" bIns="0">
-            <a:spAutoFit/>
-          </a:bodyPr>
-          <a:lstStyle/>
-          <a:p>
-            <a:pPr algn="l">
-              <a:lnSpc>
-                <a:spcPct val="125000"/>
-              </a:lnSpc>
-              <a:spcAft>
-                <a:spcPts val="600"/>
-              </a:spcAft>
-            </a:pPr>
-            <a:r>
-              <a:rPr sz="700" b="0">
-                <a:solidFill>
-                  <a:srgbClr val="E4E4E7"/>
-                </a:solidFill>
-                <a:latin typeface="Consolas"/>
-              </a:rPr>
-              <a:t>base 0.50 -&gt; raw 1.15 -&gt; score 0.95  SUCCEEDED</a:t>
-            </a:r>
-          </a:p>
-        </p:txBody>
-      </p:sp>
-      <p:sp>
-        <p:nvSpPr>
-          <p:cNvPr id="55" name="Rounded Rectangle 54"/>
+      <p:pic>
+        <p:nvPicPr>
+          <p:cNvPr id="7" name="Picture 6" descr="viewer-overview.png"/>
+          <p:cNvPicPr>
+            <a:picLocks noChangeAspect="1"/>
+          </p:cNvPicPr>
+          <p:nvPr/>
+        </p:nvPicPr>
+        <p:blipFill>
+          <a:blip r:embed="rId2"/>
+          <a:stretch>
+            <a:fillRect/>
+          </a:stretch>
+        </p:blipFill>
+        <p:spPr>
+          <a:xfrm>
+            <a:off x="1104595" y="1810512"/>
+            <a:ext cx="6203289" cy="3877056"/>
+          </a:xfrm>
+          <a:prstGeom prst="rect">
+            <a:avLst/>
+          </a:prstGeom>
+        </p:spPr>
+      </p:pic>
+      <p:sp>
+        <p:nvSpPr>
+          <p:cNvPr id="8" name="Rounded Rectangle 7"/>
           <p:cNvSpPr/>
           <p:nvPr/>
         </p:nvSpPr>
@@ -14225,7 +10953,7 @@
       </p:sp>
       <p:sp>
         <p:nvSpPr>
-          <p:cNvPr id="56" name="Rectangle 55"/>
+          <p:cNvPr id="9" name="Rectangle 8"/>
           <p:cNvSpPr/>
           <p:nvPr/>
         </p:nvSpPr>
@@ -14269,7 +10997,7 @@
       </p:sp>
       <p:sp>
         <p:nvSpPr>
-          <p:cNvPr id="57" name="TextBox 56"/>
+          <p:cNvPr id="10" name="TextBox 9"/>
           <p:cNvSpPr txBox="1"/>
           <p:nvPr/>
         </p:nvSpPr>
@@ -14311,7 +11039,7 @@
       </p:sp>
       <p:sp>
         <p:nvSpPr>
-          <p:cNvPr id="58" name="TextBox 57"/>
+          <p:cNvPr id="11" name="TextBox 10"/>
           <p:cNvSpPr txBox="1"/>
           <p:nvPr/>
         </p:nvSpPr>
@@ -14353,7 +11081,7 @@
       </p:sp>
       <p:sp>
         <p:nvSpPr>
-          <p:cNvPr id="59" name="Rounded Rectangle 58"/>
+          <p:cNvPr id="12" name="Rounded Rectangle 11"/>
           <p:cNvSpPr/>
           <p:nvPr/>
         </p:nvSpPr>
@@ -14401,7 +11129,7 @@
       </p:sp>
       <p:sp>
         <p:nvSpPr>
-          <p:cNvPr id="60" name="Rectangle 59"/>
+          <p:cNvPr id="13" name="Rectangle 12"/>
           <p:cNvSpPr/>
           <p:nvPr/>
         </p:nvSpPr>
@@ -14445,7 +11173,7 @@
       </p:sp>
       <p:sp>
         <p:nvSpPr>
-          <p:cNvPr id="61" name="TextBox 60"/>
+          <p:cNvPr id="14" name="TextBox 13"/>
           <p:cNvSpPr txBox="1"/>
           <p:nvPr/>
         </p:nvSpPr>
@@ -14487,7 +11215,7 @@
       </p:sp>
       <p:sp>
         <p:nvSpPr>
-          <p:cNvPr id="62" name="TextBox 61"/>
+          <p:cNvPr id="15" name="TextBox 14"/>
           <p:cNvSpPr txBox="1"/>
           <p:nvPr/>
         </p:nvSpPr>
@@ -14529,7 +11257,7 @@
       </p:sp>
       <p:sp>
         <p:nvSpPr>
-          <p:cNvPr id="63" name="Rounded Rectangle 62"/>
+          <p:cNvPr id="16" name="Rounded Rectangle 15"/>
           <p:cNvSpPr/>
           <p:nvPr/>
         </p:nvSpPr>
@@ -14577,7 +11305,7 @@
       </p:sp>
       <p:sp>
         <p:nvSpPr>
-          <p:cNvPr id="64" name="Rectangle 63"/>
+          <p:cNvPr id="17" name="Rectangle 16"/>
           <p:cNvSpPr/>
           <p:nvPr/>
         </p:nvSpPr>
@@ -14621,7 +11349,7 @@
       </p:sp>
       <p:sp>
         <p:nvSpPr>
-          <p:cNvPr id="65" name="TextBox 64"/>
+          <p:cNvPr id="18" name="TextBox 17"/>
           <p:cNvSpPr txBox="1"/>
           <p:nvPr/>
         </p:nvSpPr>
@@ -14663,7 +11391,7 @@
       </p:sp>
       <p:sp>
         <p:nvSpPr>
-          <p:cNvPr id="66" name="TextBox 65"/>
+          <p:cNvPr id="19" name="TextBox 18"/>
           <p:cNvSpPr txBox="1"/>
           <p:nvPr/>
         </p:nvSpPr>
@@ -14705,7 +11433,7 @@
       </p:sp>
       <p:sp>
         <p:nvSpPr>
-          <p:cNvPr id="67" name="Rounded Rectangle 66"/>
+          <p:cNvPr id="20" name="Rounded Rectangle 19"/>
           <p:cNvSpPr/>
           <p:nvPr/>
         </p:nvSpPr>
@@ -14753,7 +11481,7 @@
       </p:sp>
       <p:sp>
         <p:nvSpPr>
-          <p:cNvPr id="68" name="Rectangle 67"/>
+          <p:cNvPr id="21" name="Rectangle 20"/>
           <p:cNvSpPr/>
           <p:nvPr/>
         </p:nvSpPr>
@@ -14797,7 +11525,7 @@
       </p:sp>
       <p:sp>
         <p:nvSpPr>
-          <p:cNvPr id="69" name="TextBox 68"/>
+          <p:cNvPr id="22" name="TextBox 21"/>
           <p:cNvSpPr txBox="1"/>
           <p:nvPr/>
         </p:nvSpPr>
@@ -14839,7 +11567,7 @@
       </p:sp>
       <p:sp>
         <p:nvSpPr>
-          <p:cNvPr id="70" name="TextBox 69"/>
+          <p:cNvPr id="23" name="TextBox 22"/>
           <p:cNvSpPr txBox="1"/>
           <p:nvPr/>
         </p:nvSpPr>
@@ -14881,7 +11609,7 @@
       </p:sp>
       <p:sp>
         <p:nvSpPr>
-          <p:cNvPr id="71" name="TextBox 70"/>
+          <p:cNvPr id="24" name="TextBox 23"/>
           <p:cNvSpPr txBox="1"/>
           <p:nvPr/>
         </p:nvSpPr>

</xml_diff>

<commit_message>
Deck: add the video demo link to the Submission Links slide
</commit_message>
<xml_diff>
--- a/deck.pptx
+++ b/deck.pptx
@@ -4604,7 +4604,9 @@
       </p:sp>
       <p:sp>
         <p:nvSpPr>
-          <p:cNvPr id="8" name="Rounded Rectangle 7"/>
+          <p:cNvPr id="8" name="Rounded Rectangle 7">
+            <a:hlinkClick r:id="rId3"/>
+          </p:cNvPr>
           <p:cNvSpPr/>
           <p:nvPr/>
         </p:nvSpPr>
@@ -4739,13 +4741,14 @@
               </a:spcBef>
             </a:pPr>
             <a:r>
-              <a:rPr sz="1700">
-                <a:solidFill>
-                  <a:srgbClr val="8A8A94"/>
+              <a:rPr u="sng" sz="1700">
+                <a:solidFill>
+                  <a:srgbClr val="E2551F"/>
                 </a:solidFill>
                 <a:latin typeface="Consolas"/>
-              </a:rPr>
-              <a:t>[Insert Link]</a:t>
+                <a:hlinkClick r:id="rId3"/>
+              </a:rPr>
+              <a:t>https://drive.google.com/drive/folders/1V1epYDk68tn1xAN9PbFEI_mInAyOuvKy</a:t>
             </a:r>
           </a:p>
         </p:txBody>
@@ -4795,7 +4798,7 @@
                   <a:srgbClr val="E2551F"/>
                 </a:solidFill>
                 <a:latin typeface="Consolas"/>
-                <a:hlinkClick r:id="rId3"/>
+                <a:hlinkClick r:id="rId4"/>
               </a:rPr>
               <a:t>soc-agent-trace-viewer.vercel.app</a:t>
             </a:r>

</xml_diff>